<commit_message>
Rebuild Responsible AI deck: platform-first, dense, with examples
Reframed so the LLMOps platform is the subject and APIX is the example
use case (was APIX-first). Same density as the metrics deck — 8 slides:
platform-vs-RAI maturity framing, the 6 commitments with per-use-case
examples, a bolt-on-vs-platform-layer comparison, the capability mapping,
APIX as the worked example, fairness + transparency worked examples, and
the protected->governed maturity path.

Co-Authored-By: Claude Opus 4.8 (1M context) <noreply@anthropic.com>
</commit_message>
<xml_diff>
--- a/usecases/ai_pipeline 2/docs/Responsible_AI_for_APIX.pptx
+++ b/usecases/ai_pipeline 2/docs/Responsible_AI_for_APIX.pptx
@@ -3123,6 +3123,7 @@
           <a:ln>
             <a:noFill/>
           </a:ln>
+          <a:effectLst/>
         </p:spPr>
         <p:style>
           <a:lnRef idx="1">
@@ -3154,8 +3155,8 @@
         </p:nvSpPr>
         <p:spPr>
           <a:xfrm>
-            <a:off x="731520" y="2011680"/>
-            <a:ext cx="10698480" cy="2926080"/>
+            <a:off x="731520" y="1874519"/>
+            <a:ext cx="10881360" cy="3108960"/>
           </a:xfrm>
           <a:prstGeom prst="rect">
             <a:avLst/>
@@ -3174,13 +3175,13 @@
               </a:spcAft>
             </a:pPr>
             <a:r>
-              <a:rPr sz="1400" b="1">
+              <a:rPr sz="1350" b="1">
                 <a:solidFill>
                   <a:srgbClr val="0E7C74"/>
                 </a:solidFill>
                 <a:latin typeface="Segoe UI"/>
               </a:rPr>
-              <a:t>RESPONSIBLE AI  ·  APIX</a:t>
+              <a:t>LLMOps PLATFORM  ·  RESPONSIBLE AI</a:t>
             </a:r>
           </a:p>
           <a:p>
@@ -3190,29 +3191,29 @@
               </a:spcAft>
             </a:pPr>
             <a:r>
-              <a:rPr sz="3800" b="1">
+              <a:rPr sz="3700" b="1">
                 <a:solidFill>
                   <a:srgbClr val="1A1F27"/>
                 </a:solidFill>
                 <a:latin typeface="Segoe UI"/>
               </a:rPr>
-              <a:t>Responsible AI —</a:t>
+              <a:t>Responsible AI for the</a:t>
             </a:r>
           </a:p>
           <a:p>
             <a:pPr>
               <a:spcAft>
-                <a:spcPts val="1600"/>
+                <a:spcPts val="1500"/>
               </a:spcAft>
             </a:pPr>
             <a:r>
-              <a:rPr sz="3800" b="1">
+              <a:rPr sz="3700" b="1">
                 <a:solidFill>
                   <a:srgbClr val="1A1F27"/>
                 </a:solidFill>
                 <a:latin typeface="Segoe UI"/>
               </a:rPr>
-              <a:t>how it strengthens the platform and APIX</a:t>
+              <a:t>LLMOps platform</a:t>
             </a:r>
           </a:p>
           <a:p>
@@ -3222,13 +3223,13 @@
               </a:spcAft>
             </a:pPr>
             <a:r>
-              <a:rPr sz="1800" b="0">
+              <a:rPr sz="1700" b="0">
                 <a:solidFill>
                   <a:srgbClr val="535C6A"/>
                 </a:solidFill>
                 <a:latin typeface="Segoe UI"/>
               </a:rPr>
-              <a:t>APIX = AFNI Performance Index.  A short, plain-language overview for discussion.</a:t>
+              <a:t>The maturity layer that makes every AI use case on the platform trustworthy — shown with APIX (AFNI Performance Index) as the example.</a:t>
             </a:r>
           </a:p>
         </p:txBody>
@@ -3241,8 +3242,8 @@
         </p:nvSpPr>
         <p:spPr>
           <a:xfrm>
-            <a:off x="731520" y="5852160"/>
-            <a:ext cx="10698480" cy="640080"/>
+            <a:off x="731520" y="5897880"/>
+            <a:ext cx="10881360" cy="640080"/>
           </a:xfrm>
           <a:prstGeom prst="rect">
             <a:avLst/>
@@ -3261,13 +3262,13 @@
               </a:spcAft>
             </a:pPr>
             <a:r>
-              <a:rPr sz="1350" b="0">
+              <a:rPr sz="1250" b="0">
                 <a:solidFill>
                   <a:srgbClr val="8A93A1"/>
                 </a:solidFill>
                 <a:latin typeface="Segoe UI"/>
               </a:rPr>
-              <a:t>Fair  ·  Safe  ·  Private  ·  Clear  ·  Human-controlled   —   9 Sep 2026</a:t>
+              <a:t>One platform · many use cases · APIX is the first      Fair · Safe · Private · Clear · Human-controlled      9 Sep 2026</a:t>
             </a:r>
           </a:p>
         </p:txBody>
@@ -3318,6 +3319,7 @@
           <a:ln>
             <a:noFill/>
           </a:ln>
+          <a:effectLst/>
         </p:spPr>
         <p:style>
           <a:lnRef idx="1">
@@ -3349,8 +3351,8 @@
         </p:nvSpPr>
         <p:spPr>
           <a:xfrm>
-            <a:off x="640080" y="384048"/>
-            <a:ext cx="11155680" cy="1280160"/>
+            <a:off x="640080" y="365760"/>
+            <a:ext cx="11247120" cy="1234440"/>
           </a:xfrm>
           <a:prstGeom prst="rect">
             <a:avLst/>
@@ -3365,17 +3367,17 @@
           <a:p>
             <a:pPr>
               <a:spcAft>
-                <a:spcPts val="500"/>
+                <a:spcPts val="400"/>
               </a:spcAft>
             </a:pPr>
             <a:r>
-              <a:rPr sz="1250" b="1">
+              <a:rPr sz="1200" b="1">
                 <a:solidFill>
                   <a:srgbClr val="0E7C74"/>
                 </a:solidFill>
                 <a:latin typeface="Segoe UI"/>
               </a:rPr>
-              <a:t>1 · THE IDEA</a:t>
+              <a:t>THE FRAME</a:t>
             </a:r>
           </a:p>
           <a:p>
@@ -3385,13 +3387,13 @@
               </a:spcAft>
             </a:pPr>
             <a:r>
-              <a:rPr sz="2700" b="1">
+              <a:rPr sz="2500" b="1">
                 <a:solidFill>
                   <a:srgbClr val="1A1F27"/>
                 </a:solidFill>
                 <a:latin typeface="Segoe UI"/>
               </a:rPr>
-              <a:t>What Responsible AI means</a:t>
+              <a:t>Responsible AI belongs to the platform, not one app</a:t>
             </a:r>
           </a:p>
         </p:txBody>
@@ -3404,8 +3406,8 @@
         </p:nvSpPr>
         <p:spPr>
           <a:xfrm>
-            <a:off x="685800" y="1874519"/>
-            <a:ext cx="10881360" cy="4206240"/>
+            <a:off x="685800" y="1554480"/>
+            <a:ext cx="10881360" cy="548640"/>
           </a:xfrm>
           <a:prstGeom prst="rect">
             <a:avLst/>
@@ -3420,57 +3422,44 @@
           <a:p>
             <a:pPr>
               <a:spcAft>
-                <a:spcPts val="1600"/>
+                <a:spcPts val="0"/>
               </a:spcAft>
             </a:pPr>
             <a:r>
-              <a:rPr sz="1800" b="0">
-                <a:solidFill>
-                  <a:srgbClr val="1A1F27"/>
+              <a:rPr sz="1400" b="0">
+                <a:solidFill>
+                  <a:srgbClr val="535C6A"/>
                 </a:solidFill>
                 <a:latin typeface="Segoe UI"/>
               </a:rPr>
-              <a:t>A set of practices that make an AI system fair, safe, private, clear about how it works, and always under human control.</a:t>
-            </a:r>
-          </a:p>
-          <a:p>
-            <a:pPr>
-              <a:spcAft>
-                <a:spcPts val="1600"/>
-              </a:spcAft>
-            </a:pPr>
-            <a:r>
-              <a:rPr sz="1800" b="0">
-                <a:solidFill>
-                  <a:srgbClr val="1A1F27"/>
-                </a:solidFill>
-                <a:latin typeface="Segoe UI"/>
-              </a:rPr>
-              <a:t>It is not a product you buy — it is how the system is built, checked, and run.</a:t>
-            </a:r>
-          </a:p>
-        </p:txBody>
-      </p:sp>
-      <p:sp>
-        <p:nvSpPr>
-          <p:cNvPr id="5" name="Rectangle 4"/>
+              <a:t>The LLMOps platform runs many AI use cases (APIX today; hiring intelligence, agent-assist, quality-scoring next). Responsible AI is a layer added once, on the platform — every use case inherits it.</a:t>
+            </a:r>
+          </a:p>
+        </p:txBody>
+      </p:sp>
+      <p:sp>
+        <p:nvSpPr>
+          <p:cNvPr id="5" name="Rounded Rectangle 4"/>
           <p:cNvSpPr/>
           <p:nvPr/>
         </p:nvSpPr>
         <p:spPr>
           <a:xfrm>
-            <a:off x="685800" y="3931920"/>
-            <a:ext cx="10881360" cy="868680"/>
+            <a:off x="640080" y="2331720"/>
+            <a:ext cx="5486400" cy="3108960"/>
           </a:xfrm>
-          <a:prstGeom prst="rect">
+          <a:prstGeom prst="roundRect">
             <a:avLst/>
           </a:prstGeom>
           <a:solidFill>
-            <a:srgbClr val="F2F5F4"/>
+            <a:srgbClr val="E1F0EE"/>
           </a:solidFill>
-          <a:ln>
-            <a:noFill/>
+          <a:ln w="9525">
+            <a:solidFill>
+              <a:srgbClr val="D9DFE5"/>
+            </a:solidFill>
           </a:ln>
+          <a:effectLst/>
         </p:spPr>
         <p:style>
           <a:lnRef idx="1">
@@ -3487,7 +3476,283 @@
           </a:fontRef>
         </p:style>
         <p:txBody>
-          <a:bodyPr rtlCol="0" anchor="ctr" wrap="square" lIns="228600" rIns="228600"/>
+          <a:bodyPr rtlCol="0" anchor="ctr" wrap="square" lIns="146304" rIns="128016" tIns="118872" bIns="91440"/>
+          <a:lstStyle/>
+          <a:p>
+            <a:pPr algn="ctr">
+              <a:spcAft>
+                <a:spcPts val="700"/>
+              </a:spcAft>
+            </a:pPr>
+            <a:r>
+              <a:rPr sz="1250" b="1">
+                <a:solidFill>
+                  <a:srgbClr val="0E7C74"/>
+                </a:solidFill>
+                <a:latin typeface="Segoe UI"/>
+              </a:rPr>
+              <a:t>The platform makes AI  WORK</a:t>
+            </a:r>
+          </a:p>
+          <a:p>
+            <a:pPr>
+              <a:spcAft>
+                <a:spcPts val="300"/>
+              </a:spcAft>
+            </a:pPr>
+            <a:r>
+              <a:rPr sz="1150" b="0">
+                <a:solidFill>
+                  <a:srgbClr val="535C6A"/>
+                </a:solidFill>
+                <a:latin typeface="Segoe UI"/>
+              </a:rPr>
+              <a:t>Runs prompts &amp; models reliably</a:t>
+            </a:r>
+          </a:p>
+          <a:p>
+            <a:pPr>
+              <a:spcAft>
+                <a:spcPts val="300"/>
+              </a:spcAft>
+            </a:pPr>
+            <a:r>
+              <a:rPr sz="1150" b="0">
+                <a:solidFill>
+                  <a:srgbClr val="535C6A"/>
+                </a:solidFill>
+                <a:latin typeface="Segoe UI"/>
+              </a:rPr>
+              <a:t>Checks quality before release</a:t>
+            </a:r>
+          </a:p>
+          <a:p>
+            <a:pPr>
+              <a:spcAft>
+                <a:spcPts val="300"/>
+              </a:spcAft>
+            </a:pPr>
+            <a:r>
+              <a:rPr sz="1150" b="0">
+                <a:solidFill>
+                  <a:srgbClr val="535C6A"/>
+                </a:solidFill>
+                <a:latin typeface="Segoe UI"/>
+              </a:rPr>
+              <a:t>Monitors cost, speed, errors</a:t>
+            </a:r>
+          </a:p>
+          <a:p>
+            <a:pPr>
+              <a:spcAft>
+                <a:spcPts val="300"/>
+              </a:spcAft>
+            </a:pPr>
+            <a:r>
+              <a:rPr sz="1150" b="0">
+                <a:solidFill>
+                  <a:srgbClr val="1A1F27"/>
+                </a:solidFill>
+                <a:latin typeface="Segoe UI"/>
+              </a:rPr>
+              <a:t/>
+            </a:r>
+          </a:p>
+          <a:p>
+            <a:pPr>
+              <a:spcAft>
+                <a:spcPts val="300"/>
+              </a:spcAft>
+            </a:pPr>
+            <a:r>
+              <a:rPr sz="1150" b="0">
+                <a:solidFill>
+                  <a:srgbClr val="0A5B55"/>
+                </a:solidFill>
+                <a:latin typeface="Segoe UI"/>
+              </a:rPr>
+              <a:t>→ reliable</a:t>
+            </a:r>
+          </a:p>
+        </p:txBody>
+      </p:sp>
+      <p:sp>
+        <p:nvSpPr>
+          <p:cNvPr id="6" name="Rounded Rectangle 5"/>
+          <p:cNvSpPr/>
+          <p:nvPr/>
+        </p:nvSpPr>
+        <p:spPr>
+          <a:xfrm>
+            <a:off x="6355080" y="2331720"/>
+            <a:ext cx="5212080" cy="3108960"/>
+          </a:xfrm>
+          <a:prstGeom prst="roundRect">
+            <a:avLst/>
+          </a:prstGeom>
+          <a:solidFill>
+            <a:srgbClr val="E4F3EB"/>
+          </a:solidFill>
+          <a:ln w="9525">
+            <a:solidFill>
+              <a:srgbClr val="D9DFE5"/>
+            </a:solidFill>
+          </a:ln>
+          <a:effectLst/>
+        </p:spPr>
+        <p:style>
+          <a:lnRef idx="1">
+            <a:schemeClr val="accent1"/>
+          </a:lnRef>
+          <a:fillRef idx="3">
+            <a:schemeClr val="accent1"/>
+          </a:fillRef>
+          <a:effectRef idx="2">
+            <a:schemeClr val="accent1"/>
+          </a:effectRef>
+          <a:fontRef idx="minor">
+            <a:schemeClr val="lt1"/>
+          </a:fontRef>
+        </p:style>
+        <p:txBody>
+          <a:bodyPr rtlCol="0" anchor="ctr" wrap="square" lIns="146304" rIns="128016" tIns="118872" bIns="91440"/>
+          <a:lstStyle/>
+          <a:p>
+            <a:pPr algn="ctr">
+              <a:spcAft>
+                <a:spcPts val="700"/>
+              </a:spcAft>
+            </a:pPr>
+            <a:r>
+              <a:rPr sz="1250" b="1">
+                <a:solidFill>
+                  <a:srgbClr val="2E8B5E"/>
+                </a:solidFill>
+                <a:latin typeface="Segoe UI"/>
+              </a:rPr>
+              <a:t>Responsible AI makes AI  TRUSTED</a:t>
+            </a:r>
+          </a:p>
+          <a:p>
+            <a:pPr>
+              <a:spcAft>
+                <a:spcPts val="300"/>
+              </a:spcAft>
+            </a:pPr>
+            <a:r>
+              <a:rPr sz="1150" b="0">
+                <a:solidFill>
+                  <a:srgbClr val="535C6A"/>
+                </a:solidFill>
+                <a:latin typeface="Segoe UI"/>
+              </a:rPr>
+              <a:t>Fair · safe · private</a:t>
+            </a:r>
+          </a:p>
+          <a:p>
+            <a:pPr>
+              <a:spcAft>
+                <a:spcPts val="300"/>
+              </a:spcAft>
+            </a:pPr>
+            <a:r>
+              <a:rPr sz="1150" b="0">
+                <a:solidFill>
+                  <a:srgbClr val="535C6A"/>
+                </a:solidFill>
+                <a:latin typeface="Segoe UI"/>
+              </a:rPr>
+              <a:t>Explainable &amp; contestable</a:t>
+            </a:r>
+          </a:p>
+          <a:p>
+            <a:pPr>
+              <a:spcAft>
+                <a:spcPts val="300"/>
+              </a:spcAft>
+            </a:pPr>
+            <a:r>
+              <a:rPr sz="1150" b="0">
+                <a:solidFill>
+                  <a:srgbClr val="535C6A"/>
+                </a:solidFill>
+                <a:latin typeface="Segoe UI"/>
+              </a:rPr>
+              <a:t>Kept under human control</a:t>
+            </a:r>
+          </a:p>
+          <a:p>
+            <a:pPr>
+              <a:spcAft>
+                <a:spcPts val="300"/>
+              </a:spcAft>
+            </a:pPr>
+            <a:r>
+              <a:rPr sz="1150" b="0">
+                <a:solidFill>
+                  <a:srgbClr val="1A1F27"/>
+                </a:solidFill>
+                <a:latin typeface="Segoe UI"/>
+              </a:rPr>
+              <a:t/>
+            </a:r>
+          </a:p>
+          <a:p>
+            <a:pPr>
+              <a:spcAft>
+                <a:spcPts val="300"/>
+              </a:spcAft>
+            </a:pPr>
+            <a:r>
+              <a:rPr sz="1150" b="0">
+                <a:solidFill>
+                  <a:srgbClr val="2E8B5E"/>
+                </a:solidFill>
+                <a:latin typeface="Segoe UI"/>
+              </a:rPr>
+              <a:t>→ trustworthy &amp; defensible</a:t>
+            </a:r>
+          </a:p>
+        </p:txBody>
+      </p:sp>
+      <p:sp>
+        <p:nvSpPr>
+          <p:cNvPr id="7" name="Rounded Rectangle 6"/>
+          <p:cNvSpPr/>
+          <p:nvPr/>
+        </p:nvSpPr>
+        <p:spPr>
+          <a:xfrm>
+            <a:off x="640080" y="5806440"/>
+            <a:ext cx="10927080" cy="749808"/>
+          </a:xfrm>
+          <a:prstGeom prst="roundRect">
+            <a:avLst/>
+          </a:prstGeom>
+          <a:solidFill>
+            <a:srgbClr val="E1F0EE"/>
+          </a:solidFill>
+          <a:ln>
+            <a:noFill/>
+          </a:ln>
+          <a:effectLst/>
+        </p:spPr>
+        <p:style>
+          <a:lnRef idx="1">
+            <a:schemeClr val="accent1"/>
+          </a:lnRef>
+          <a:fillRef idx="3">
+            <a:schemeClr val="accent1"/>
+          </a:fillRef>
+          <a:effectRef idx="2">
+            <a:schemeClr val="accent1"/>
+          </a:effectRef>
+          <a:fontRef idx="minor">
+            <a:schemeClr val="lt1"/>
+          </a:fontRef>
+        </p:style>
+        <p:txBody>
+          <a:bodyPr rtlCol="0" anchor="ctr" wrap="square" lIns="201168" rIns="201168"/>
           <a:lstStyle/>
           <a:p>
             <a:pPr algn="ctr">
@@ -3496,13 +3761,13 @@
               </a:spcAft>
             </a:pPr>
             <a:r>
-              <a:rPr sz="1600" b="1">
-                <a:solidFill>
-                  <a:srgbClr val="0E7C74"/>
+              <a:rPr sz="1400" b="1">
+                <a:solidFill>
+                  <a:srgbClr val="0A5B55"/>
                 </a:solidFill>
                 <a:latin typeface="Segoe UI"/>
               </a:rPr>
-              <a:t>If the platform makes our AI work, Responsible AI makes it trusted — and lets us prove it if a client, auditor, or regulator asks.</a:t>
+              <a:t>The platform is built. Responsible AI is the next layer — added once and inherited by every use case, APIX included.</a:t>
             </a:r>
           </a:p>
         </p:txBody>
@@ -3553,6 +3818,7 @@
           <a:ln>
             <a:noFill/>
           </a:ln>
+          <a:effectLst/>
         </p:spPr>
         <p:style>
           <a:lnRef idx="1">
@@ -3584,8 +3850,8 @@
         </p:nvSpPr>
         <p:spPr>
           <a:xfrm>
-            <a:off x="640080" y="384048"/>
-            <a:ext cx="11155680" cy="1280160"/>
+            <a:off x="640080" y="365760"/>
+            <a:ext cx="11247120" cy="1234440"/>
           </a:xfrm>
           <a:prstGeom prst="rect">
             <a:avLst/>
@@ -3600,17 +3866,17 @@
           <a:p>
             <a:pPr>
               <a:spcAft>
-                <a:spcPts val="500"/>
+                <a:spcPts val="400"/>
               </a:spcAft>
             </a:pPr>
             <a:r>
-              <a:rPr sz="1250" b="1">
+              <a:rPr sz="1200" b="1">
                 <a:solidFill>
                   <a:srgbClr val="0E7C74"/>
                 </a:solidFill>
                 <a:latin typeface="Segoe UI"/>
               </a:rPr>
-              <a:t>2 · THE PARTS</a:t>
+              <a:t>WHAT IT IS</a:t>
             </a:r>
           </a:p>
           <a:p>
@@ -3620,13 +3886,13 @@
               </a:spcAft>
             </a:pPr>
             <a:r>
-              <a:rPr sz="2700" b="1">
+              <a:rPr sz="2500" b="1">
                 <a:solidFill>
                   <a:srgbClr val="1A1F27"/>
                 </a:solidFill>
                 <a:latin typeface="Segoe UI"/>
               </a:rPr>
-              <a:t>What it includes</a:t>
+              <a:t>Six commitments — with an example in a use case</a:t>
             </a:r>
           </a:p>
         </p:txBody>
@@ -3640,8 +3906,8 @@
           <p:nvPr/>
         </p:nvGraphicFramePr>
         <p:xfrm>
-          <a:off x="640080" y="1783080"/>
-          <a:ext cx="10927080" cy="3968496"/>
+          <a:off x="640080" y="1828800"/>
+          <a:ext cx="10927080" cy="4224528"/>
         </p:xfrm>
         <a:graphic>
           <a:graphicData uri="http://schemas.openxmlformats.org/drawingml/2006/table">
@@ -3650,17 +3916,18 @@
                 <a:tableStyleId>{5C22544A-7EE6-4342-B048-85BDC9FD1C3A}</a:tableStyleId>
               </a:tblPr>
               <a:tblGrid>
-                <a:gridCol w="2834640"/>
-                <a:gridCol w="8092440"/>
+                <a:gridCol w="2286000"/>
+                <a:gridCol w="4023360"/>
+                <a:gridCol w="4617720"/>
               </a:tblGrid>
-              <a:tr h="566928">
+              <a:tr h="603504">
                 <a:tc>
                   <a:txBody>
                     <a:bodyPr wrap="square"/>
                     <a:lstStyle/>
                     <a:p>
                       <a:r>
-                        <a:rPr sz="1150" b="1">
+                        <a:rPr sz="1100" b="1">
                           <a:solidFill>
                             <a:srgbClr val="FFFFFF"/>
                           </a:solidFill>
@@ -3670,7 +3937,7 @@
                       </a:r>
                     </a:p>
                   </a:txBody>
-                  <a:tcPr anchor="ctr" marL="91440" marR="54864" marT="27432" marB="27432">
+                  <a:tcPr anchor="ctr" marL="91440" marR="54864" marT="18288" marB="18288">
                     <a:solidFill>
                       <a:srgbClr val="0E7C74"/>
                     </a:solidFill>
@@ -3682,7 +3949,7 @@
                     <a:lstStyle/>
                     <a:p>
                       <a:r>
-                        <a:rPr sz="1150" b="1">
+                        <a:rPr sz="1100" b="1">
                           <a:solidFill>
                             <a:srgbClr val="FFFFFF"/>
                           </a:solidFill>
@@ -3692,21 +3959,43 @@
                       </a:r>
                     </a:p>
                   </a:txBody>
-                  <a:tcPr anchor="ctr" marL="91440" marR="54864" marT="27432" marB="27432">
+                  <a:tcPr anchor="ctr" marL="91440" marR="54864" marT="18288" marB="18288">
+                    <a:solidFill>
+                      <a:srgbClr val="0E7C74"/>
+                    </a:solidFill>
+                  </a:tcPr>
+                </a:tc>
+                <a:tc>
+                  <a:txBody>
+                    <a:bodyPr wrap="square"/>
+                    <a:lstStyle/>
+                    <a:p>
+                      <a:r>
+                        <a:rPr sz="1100" b="1">
+                          <a:solidFill>
+                            <a:srgbClr val="FFFFFF"/>
+                          </a:solidFill>
+                          <a:latin typeface="Segoe UI"/>
+                        </a:rPr>
+                        <a:t>Example (in APIX)</a:t>
+                      </a:r>
+                    </a:p>
+                  </a:txBody>
+                  <a:tcPr anchor="ctr" marL="91440" marR="54864" marT="18288" marB="18288">
                     <a:solidFill>
                       <a:srgbClr val="0E7C74"/>
                     </a:solidFill>
                   </a:tcPr>
                 </a:tc>
               </a:tr>
-              <a:tr h="566928">
+              <a:tr h="603504">
                 <a:tc>
                   <a:txBody>
                     <a:bodyPr wrap="square"/>
                     <a:lstStyle/>
                     <a:p>
                       <a:r>
-                        <a:rPr sz="1400" b="1">
+                        <a:rPr sz="1250" b="1">
                           <a:solidFill>
                             <a:srgbClr val="1A1F27"/>
                           </a:solidFill>
@@ -3716,7 +4005,7 @@
                       </a:r>
                     </a:p>
                   </a:txBody>
-                  <a:tcPr anchor="ctr" marL="91440" marR="54864" marT="27432" marB="27432">
+                  <a:tcPr anchor="ctr" marL="91440" marR="54864" marT="18288" marB="18288">
                     <a:solidFill>
                       <a:srgbClr val="FFFFFF"/>
                     </a:solidFill>
@@ -3728,31 +4017,53 @@
                     <a:lstStyle/>
                     <a:p>
                       <a:r>
-                        <a:rPr sz="1400" b="0">
+                        <a:rPr sz="1250" b="0">
                           <a:solidFill>
                             <a:srgbClr val="535C6A"/>
                           </a:solidFill>
                           <a:latin typeface="Segoe UI"/>
                         </a:rPr>
-                        <a:t>Treats people evenly, with no hidden bias against any group</a:t>
+                        <a:t>Treats people evenly, no hidden bias</a:t>
                       </a:r>
                     </a:p>
                   </a:txBody>
-                  <a:tcPr anchor="ctr" marL="91440" marR="54864" marT="27432" marB="27432">
+                  <a:tcPr anchor="ctr" marL="91440" marR="54864" marT="18288" marB="18288">
+                    <a:solidFill>
+                      <a:srgbClr val="FFFFFF"/>
+                    </a:solidFill>
+                  </a:tcPr>
+                </a:tc>
+                <a:tc>
+                  <a:txBody>
+                    <a:bodyPr wrap="square"/>
+                    <a:lstStyle/>
+                    <a:p>
+                      <a:r>
+                        <a:rPr sz="1250" b="0">
+                          <a:solidFill>
+                            <a:srgbClr val="535C6A"/>
+                          </a:solidFill>
+                          <a:latin typeface="Segoe UI"/>
+                        </a:rPr>
+                        <a:t>Scores don't penalise accented agents</a:t>
+                      </a:r>
+                    </a:p>
+                  </a:txBody>
+                  <a:tcPr anchor="ctr" marL="91440" marR="54864" marT="18288" marB="18288">
                     <a:solidFill>
                       <a:srgbClr val="FFFFFF"/>
                     </a:solidFill>
                   </a:tcPr>
                 </a:tc>
               </a:tr>
-              <a:tr h="566928">
+              <a:tr h="603504">
                 <a:tc>
                   <a:txBody>
                     <a:bodyPr wrap="square"/>
                     <a:lstStyle/>
                     <a:p>
                       <a:r>
-                        <a:rPr sz="1400" b="1">
+                        <a:rPr sz="1250" b="1">
                           <a:solidFill>
                             <a:srgbClr val="1A1F27"/>
                           </a:solidFill>
@@ -3762,7 +4073,7 @@
                       </a:r>
                     </a:p>
                   </a:txBody>
-                  <a:tcPr anchor="ctr" marL="91440" marR="54864" marT="27432" marB="27432">
+                  <a:tcPr anchor="ctr" marL="91440" marR="54864" marT="18288" marB="18288">
                     <a:solidFill>
                       <a:srgbClr val="F7F9F8"/>
                     </a:solidFill>
@@ -3774,31 +4085,53 @@
                     <a:lstStyle/>
                     <a:p>
                       <a:r>
-                        <a:rPr sz="1400" b="0">
+                        <a:rPr sz="1250" b="0">
                           <a:solidFill>
                             <a:srgbClr val="535C6A"/>
                           </a:solidFill>
                           <a:latin typeface="Segoe UI"/>
                         </a:rPr>
-                        <a:t>Does what it should; unsafe or wrong outputs are caught early</a:t>
+                        <a:t>Catches unsafe or wrong outputs</a:t>
                       </a:r>
                     </a:p>
                   </a:txBody>
-                  <a:tcPr anchor="ctr" marL="91440" marR="54864" marT="27432" marB="27432">
+                  <a:tcPr anchor="ctr" marL="91440" marR="54864" marT="18288" marB="18288">
+                    <a:solidFill>
+                      <a:srgbClr val="F7F9F8"/>
+                    </a:solidFill>
+                  </a:tcPr>
+                </a:tc>
+                <a:tc>
+                  <a:txBody>
+                    <a:bodyPr wrap="square"/>
+                    <a:lstStyle/>
+                    <a:p>
+                      <a:r>
+                        <a:rPr sz="1250" b="0">
+                          <a:solidFill>
+                            <a:srgbClr val="535C6A"/>
+                          </a:solidFill>
+                          <a:latin typeface="Segoe UI"/>
+                        </a:rPr>
+                        <a:t>An offensive output is flagged, not shown</a:t>
+                      </a:r>
+                    </a:p>
+                  </a:txBody>
+                  <a:tcPr anchor="ctr" marL="91440" marR="54864" marT="18288" marB="18288">
                     <a:solidFill>
                       <a:srgbClr val="F7F9F8"/>
                     </a:solidFill>
                   </a:tcPr>
                 </a:tc>
               </a:tr>
-              <a:tr h="566928">
+              <a:tr h="603504">
                 <a:tc>
                   <a:txBody>
                     <a:bodyPr wrap="square"/>
                     <a:lstStyle/>
                     <a:p>
                       <a:r>
-                        <a:rPr sz="1400" b="1">
+                        <a:rPr sz="1250" b="1">
                           <a:solidFill>
                             <a:srgbClr val="1A1F27"/>
                           </a:solidFill>
@@ -3808,7 +4141,7 @@
                       </a:r>
                     </a:p>
                   </a:txBody>
-                  <a:tcPr anchor="ctr" marL="91440" marR="54864" marT="27432" marB="27432">
+                  <a:tcPr anchor="ctr" marL="91440" marR="54864" marT="18288" marB="18288">
                     <a:solidFill>
                       <a:srgbClr val="FFFFFF"/>
                     </a:solidFill>
@@ -3820,31 +4153,53 @@
                     <a:lstStyle/>
                     <a:p>
                       <a:r>
-                        <a:rPr sz="1400" b="0">
+                        <a:rPr sz="1250" b="0">
                           <a:solidFill>
                             <a:srgbClr val="535C6A"/>
                           </a:solidFill>
                           <a:latin typeface="Segoe UI"/>
                         </a:rPr>
-                        <a:t>Personal information is protected and used only as intended</a:t>
+                        <a:t>Protects personal information</a:t>
                       </a:r>
                     </a:p>
                   </a:txBody>
-                  <a:tcPr anchor="ctr" marL="91440" marR="54864" marT="27432" marB="27432">
+                  <a:tcPr anchor="ctr" marL="91440" marR="54864" marT="18288" marB="18288">
+                    <a:solidFill>
+                      <a:srgbClr val="FFFFFF"/>
+                    </a:solidFill>
+                  </a:tcPr>
+                </a:tc>
+                <a:tc>
+                  <a:txBody>
+                    <a:bodyPr wrap="square"/>
+                    <a:lstStyle/>
+                    <a:p>
+                      <a:r>
+                        <a:rPr sz="1250" b="0">
+                          <a:solidFill>
+                            <a:srgbClr val="535C6A"/>
+                          </a:solidFill>
+                          <a:latin typeface="Segoe UI"/>
+                        </a:rPr>
+                        <a:t>A card number in a call is shielded</a:t>
+                      </a:r>
+                    </a:p>
+                  </a:txBody>
+                  <a:tcPr anchor="ctr" marL="91440" marR="54864" marT="18288" marB="18288">
                     <a:solidFill>
                       <a:srgbClr val="FFFFFF"/>
                     </a:solidFill>
                   </a:tcPr>
                 </a:tc>
               </a:tr>
-              <a:tr h="566928">
+              <a:tr h="603504">
                 <a:tc>
                   <a:txBody>
                     <a:bodyPr wrap="square"/>
                     <a:lstStyle/>
                     <a:p>
                       <a:r>
-                        <a:rPr sz="1400" b="1">
+                        <a:rPr sz="1250" b="1">
                           <a:solidFill>
                             <a:srgbClr val="1A1F27"/>
                           </a:solidFill>
@@ -3854,7 +4209,7 @@
                       </a:r>
                     </a:p>
                   </a:txBody>
-                  <a:tcPr anchor="ctr" marL="91440" marR="54864" marT="27432" marB="27432">
+                  <a:tcPr anchor="ctr" marL="91440" marR="54864" marT="18288" marB="18288">
                     <a:solidFill>
                       <a:srgbClr val="F7F9F8"/>
                     </a:solidFill>
@@ -3866,31 +4221,53 @@
                     <a:lstStyle/>
                     <a:p>
                       <a:r>
-                        <a:rPr sz="1400" b="0">
+                        <a:rPr sz="1250" b="0">
                           <a:solidFill>
                             <a:srgbClr val="535C6A"/>
                           </a:solidFill>
                           <a:latin typeface="Segoe UI"/>
                         </a:rPr>
-                        <a:t>You can see and explain why it produced a result</a:t>
+                        <a:t>Explains why it produced a result</a:t>
                       </a:r>
                     </a:p>
                   </a:txBody>
-                  <a:tcPr anchor="ctr" marL="91440" marR="54864" marT="27432" marB="27432">
+                  <a:tcPr anchor="ctr" marL="91440" marR="54864" marT="18288" marB="18288">
+                    <a:solidFill>
+                      <a:srgbClr val="F7F9F8"/>
+                    </a:solidFill>
+                  </a:tcPr>
+                </a:tc>
+                <a:tc>
+                  <a:txBody>
+                    <a:bodyPr wrap="square"/>
+                    <a:lstStyle/>
+                    <a:p>
+                      <a:r>
+                        <a:rPr sz="1250" b="0">
+                          <a:solidFill>
+                            <a:srgbClr val="535C6A"/>
+                          </a:solidFill>
+                          <a:latin typeface="Segoe UI"/>
+                        </a:rPr>
+                        <a:t>Each score links to the exact call moments</a:t>
+                      </a:r>
+                    </a:p>
+                  </a:txBody>
+                  <a:tcPr anchor="ctr" marL="91440" marR="54864" marT="18288" marB="18288">
                     <a:solidFill>
                       <a:srgbClr val="F7F9F8"/>
                     </a:solidFill>
                   </a:tcPr>
                 </a:tc>
               </a:tr>
-              <a:tr h="566928">
+              <a:tr h="603504">
                 <a:tc>
                   <a:txBody>
                     <a:bodyPr wrap="square"/>
                     <a:lstStyle/>
                     <a:p>
                       <a:r>
-                        <a:rPr sz="1400" b="1">
+                        <a:rPr sz="1250" b="1">
                           <a:solidFill>
                             <a:srgbClr val="1A1F27"/>
                           </a:solidFill>
@@ -3900,7 +4277,7 @@
                       </a:r>
                     </a:p>
                   </a:txBody>
-                  <a:tcPr anchor="ctr" marL="91440" marR="54864" marT="27432" marB="27432">
+                  <a:tcPr anchor="ctr" marL="91440" marR="54864" marT="18288" marB="18288">
                     <a:solidFill>
                       <a:srgbClr val="FFFFFF"/>
                     </a:solidFill>
@@ -3912,31 +4289,53 @@
                     <a:lstStyle/>
                     <a:p>
                       <a:r>
-                        <a:rPr sz="1400" b="0">
+                        <a:rPr sz="1250" b="0">
                           <a:solidFill>
                             <a:srgbClr val="535C6A"/>
                           </a:solidFill>
                           <a:latin typeface="Segoe UI"/>
                         </a:rPr>
-                        <a:t>People stay in control; results can be reviewed and challenged</a:t>
+                        <a:t>People stay in control</a:t>
                       </a:r>
                     </a:p>
                   </a:txBody>
-                  <a:tcPr anchor="ctr" marL="91440" marR="54864" marT="27432" marB="27432">
+                  <a:tcPr anchor="ctr" marL="91440" marR="54864" marT="18288" marB="18288">
+                    <a:solidFill>
+                      <a:srgbClr val="FFFFFF"/>
+                    </a:solidFill>
+                  </a:tcPr>
+                </a:tc>
+                <a:tc>
+                  <a:txBody>
+                    <a:bodyPr wrap="square"/>
+                    <a:lstStyle/>
+                    <a:p>
+                      <a:r>
+                        <a:rPr sz="1250" b="0">
+                          <a:solidFill>
+                            <a:srgbClr val="535C6A"/>
+                          </a:solidFill>
+                          <a:latin typeface="Segoe UI"/>
+                        </a:rPr>
+                        <a:t>A coach reviews before it reaches the agent</a:t>
+                      </a:r>
+                    </a:p>
+                  </a:txBody>
+                  <a:tcPr anchor="ctr" marL="91440" marR="54864" marT="18288" marB="18288">
                     <a:solidFill>
                       <a:srgbClr val="FFFFFF"/>
                     </a:solidFill>
                   </a:tcPr>
                 </a:tc>
               </a:tr>
-              <a:tr h="566928">
+              <a:tr h="603504">
                 <a:tc>
                   <a:txBody>
                     <a:bodyPr wrap="square"/>
                     <a:lstStyle/>
                     <a:p>
                       <a:r>
-                        <a:rPr sz="1400" b="1">
+                        <a:rPr sz="1250" b="1">
                           <a:solidFill>
                             <a:srgbClr val="1A1F27"/>
                           </a:solidFill>
@@ -3946,7 +4345,7 @@
                       </a:r>
                     </a:p>
                   </a:txBody>
-                  <a:tcPr anchor="ctr" marL="91440" marR="54864" marT="27432" marB="27432">
+                  <a:tcPr anchor="ctr" marL="91440" marR="54864" marT="18288" marB="18288">
                     <a:solidFill>
                       <a:srgbClr val="F7F9F8"/>
                     </a:solidFill>
@@ -3958,17 +4357,39 @@
                     <a:lstStyle/>
                     <a:p>
                       <a:r>
-                        <a:rPr sz="1400" b="0">
+                        <a:rPr sz="1250" b="0">
                           <a:solidFill>
                             <a:srgbClr val="535C6A"/>
                           </a:solidFill>
                           <a:latin typeface="Segoe UI"/>
                         </a:rPr>
-                        <a:t>Outputs are backed by real information, not made up</a:t>
+                        <a:t>Backed by real information</a:t>
                       </a:r>
                     </a:p>
                   </a:txBody>
-                  <a:tcPr anchor="ctr" marL="91440" marR="54864" marT="27432" marB="27432">
+                  <a:tcPr anchor="ctr" marL="91440" marR="54864" marT="18288" marB="18288">
+                    <a:solidFill>
+                      <a:srgbClr val="F7F9F8"/>
+                    </a:solidFill>
+                  </a:tcPr>
+                </a:tc>
+                <a:tc>
+                  <a:txBody>
+                    <a:bodyPr wrap="square"/>
+                    <a:lstStyle/>
+                    <a:p>
+                      <a:r>
+                        <a:rPr sz="1250" b="0">
+                          <a:solidFill>
+                            <a:srgbClr val="535C6A"/>
+                          </a:solidFill>
+                          <a:latin typeface="Segoe UI"/>
+                        </a:rPr>
+                        <a:t>A coaching tip must cite the call</a:t>
+                      </a:r>
+                    </a:p>
+                  </a:txBody>
+                  <a:tcPr anchor="ctr" marL="91440" marR="54864" marT="18288" marB="18288">
                     <a:solidFill>
                       <a:srgbClr val="F7F9F8"/>
                     </a:solidFill>
@@ -4020,11 +4441,12 @@
             <a:avLst/>
           </a:prstGeom>
           <a:solidFill>
-            <a:srgbClr val="2E8B5E"/>
+            <a:srgbClr val="0E7C74"/>
           </a:solidFill>
           <a:ln>
             <a:noFill/>
           </a:ln>
+          <a:effectLst/>
         </p:spPr>
         <p:style>
           <a:lnRef idx="1">
@@ -4056,8 +4478,8 @@
         </p:nvSpPr>
         <p:spPr>
           <a:xfrm>
-            <a:off x="640080" y="384048"/>
-            <a:ext cx="11155680" cy="1280160"/>
+            <a:off x="640080" y="365760"/>
+            <a:ext cx="11247120" cy="1234440"/>
           </a:xfrm>
           <a:prstGeom prst="rect">
             <a:avLst/>
@@ -4072,17 +4494,17 @@
           <a:p>
             <a:pPr>
               <a:spcAft>
-                <a:spcPts val="500"/>
+                <a:spcPts val="400"/>
               </a:spcAft>
             </a:pPr>
             <a:r>
-              <a:rPr sz="1250" b="1">
-                <a:solidFill>
-                  <a:srgbClr val="2E8B5E"/>
+              <a:rPr sz="1200" b="1">
+                <a:solidFill>
+                  <a:srgbClr val="0E7C74"/>
                 </a:solidFill>
                 <a:latin typeface="Segoe UI"/>
               </a:rPr>
-              <a:t>3 · THE VALUE</a:t>
+              <a:t>WHY ON THE PLATFORM</a:t>
             </a:r>
           </a:p>
           <a:p>
@@ -4092,100 +4514,392 @@
               </a:spcAft>
             </a:pPr>
             <a:r>
-              <a:rPr sz="2700" b="1">
+              <a:rPr sz="2500" b="1">
                 <a:solidFill>
                   <a:srgbClr val="1A1F27"/>
                 </a:solidFill>
                 <a:latin typeface="Segoe UI"/>
               </a:rPr>
-              <a:t>Why it adds value</a:t>
-            </a:r>
-          </a:p>
-        </p:txBody>
-      </p:sp>
-      <p:sp>
-        <p:nvSpPr>
-          <p:cNvPr id="4" name="TextBox 3"/>
-          <p:cNvSpPr txBox="1"/>
+              <a:t>Build it once — every use case inherits it</a:t>
+            </a:r>
+          </a:p>
+        </p:txBody>
+      </p:sp>
+      <p:graphicFrame>
+        <p:nvGraphicFramePr>
+          <p:cNvPr id="4" name="Table 3"/>
+          <p:cNvGraphicFramePr>
+            <a:graphicFrameLocks noGrp="1"/>
+          </p:cNvGraphicFramePr>
+          <p:nvPr/>
+        </p:nvGraphicFramePr>
+        <p:xfrm>
+          <a:off x="640080" y="1828800"/>
+          <a:ext cx="10927080" cy="1920240"/>
+        </p:xfrm>
+        <a:graphic>
+          <a:graphicData uri="http://schemas.openxmlformats.org/drawingml/2006/table">
+            <a:tbl>
+              <a:tblPr firstRow="1">
+                <a:tableStyleId>{5C22544A-7EE6-4342-B048-85BDC9FD1C3A}</a:tableStyleId>
+              </a:tblPr>
+              <a:tblGrid>
+                <a:gridCol w="3017520"/>
+                <a:gridCol w="4846320"/>
+                <a:gridCol w="3063240"/>
+              </a:tblGrid>
+              <a:tr h="640080">
+                <a:tc>
+                  <a:txBody>
+                    <a:bodyPr wrap="square"/>
+                    <a:lstStyle/>
+                    <a:p>
+                      <a:r>
+                        <a:rPr sz="1100" b="1">
+                          <a:solidFill>
+                            <a:srgbClr val="FFFFFF"/>
+                          </a:solidFill>
+                          <a:latin typeface="Segoe UI"/>
+                        </a:rPr>
+                        <a:t>Approach</a:t>
+                      </a:r>
+                    </a:p>
+                  </a:txBody>
+                  <a:tcPr anchor="ctr" marL="91440" marR="54864" marT="18288" marB="18288">
+                    <a:solidFill>
+                      <a:srgbClr val="0E7C74"/>
+                    </a:solidFill>
+                  </a:tcPr>
+                </a:tc>
+                <a:tc>
+                  <a:txBody>
+                    <a:bodyPr wrap="square"/>
+                    <a:lstStyle/>
+                    <a:p>
+                      <a:r>
+                        <a:rPr sz="1100" b="1">
+                          <a:solidFill>
+                            <a:srgbClr val="FFFFFF"/>
+                          </a:solidFill>
+                          <a:latin typeface="Segoe UI"/>
+                        </a:rPr>
+                        <a:t>What it means</a:t>
+                      </a:r>
+                    </a:p>
+                  </a:txBody>
+                  <a:tcPr anchor="ctr" marL="91440" marR="54864" marT="18288" marB="18288">
+                    <a:solidFill>
+                      <a:srgbClr val="0E7C74"/>
+                    </a:solidFill>
+                  </a:tcPr>
+                </a:tc>
+                <a:tc>
+                  <a:txBody>
+                    <a:bodyPr wrap="square"/>
+                    <a:lstStyle/>
+                    <a:p>
+                      <a:r>
+                        <a:rPr sz="1100" b="1">
+                          <a:solidFill>
+                            <a:srgbClr val="FFFFFF"/>
+                          </a:solidFill>
+                          <a:latin typeface="Segoe UI"/>
+                        </a:rPr>
+                        <a:t>Result</a:t>
+                      </a:r>
+                    </a:p>
+                  </a:txBody>
+                  <a:tcPr anchor="ctr" marL="91440" marR="54864" marT="18288" marB="18288">
+                    <a:solidFill>
+                      <a:srgbClr val="0E7C74"/>
+                    </a:solidFill>
+                  </a:tcPr>
+                </a:tc>
+              </a:tr>
+              <a:tr h="640080">
+                <a:tc>
+                  <a:txBody>
+                    <a:bodyPr wrap="square"/>
+                    <a:lstStyle/>
+                    <a:p>
+                      <a:r>
+                        <a:rPr sz="1300" b="1">
+                          <a:solidFill>
+                            <a:srgbClr val="1A1F27"/>
+                          </a:solidFill>
+                          <a:latin typeface="Segoe UI"/>
+                        </a:rPr>
+                        <a:t>Bolt-on per use case</a:t>
+                      </a:r>
+                    </a:p>
+                  </a:txBody>
+                  <a:tcPr anchor="ctr" marL="91440" marR="54864" marT="18288" marB="18288">
+                    <a:solidFill>
+                      <a:srgbClr val="FFFFFF"/>
+                    </a:solidFill>
+                  </a:tcPr>
+                </a:tc>
+                <a:tc>
+                  <a:txBody>
+                    <a:bodyPr wrap="square"/>
+                    <a:lstStyle/>
+                    <a:p>
+                      <a:r>
+                        <a:rPr sz="1300" b="0">
+                          <a:solidFill>
+                            <a:srgbClr val="535C6A"/>
+                          </a:solidFill>
+                          <a:latin typeface="Segoe UI"/>
+                        </a:rPr>
+                        <a:t>Each app builds its own checks</a:t>
+                      </a:r>
+                    </a:p>
+                  </a:txBody>
+                  <a:tcPr anchor="ctr" marL="91440" marR="54864" marT="18288" marB="18288">
+                    <a:solidFill>
+                      <a:srgbClr val="FFFFFF"/>
+                    </a:solidFill>
+                  </a:tcPr>
+                </a:tc>
+                <a:tc>
+                  <a:txBody>
+                    <a:bodyPr wrap="square"/>
+                    <a:lstStyle/>
+                    <a:p>
+                      <a:r>
+                        <a:rPr sz="1300" b="0">
+                          <a:solidFill>
+                            <a:srgbClr val="535C6A"/>
+                          </a:solidFill>
+                          <a:latin typeface="Segoe UI"/>
+                        </a:rPr>
+                        <a:t>Slow · inconsistent · gaps</a:t>
+                      </a:r>
+                    </a:p>
+                  </a:txBody>
+                  <a:tcPr anchor="ctr" marL="91440" marR="54864" marT="18288" marB="18288">
+                    <a:solidFill>
+                      <a:srgbClr val="FFFFFF"/>
+                    </a:solidFill>
+                  </a:tcPr>
+                </a:tc>
+              </a:tr>
+              <a:tr h="640080">
+                <a:tc>
+                  <a:txBody>
+                    <a:bodyPr wrap="square"/>
+                    <a:lstStyle/>
+                    <a:p>
+                      <a:r>
+                        <a:rPr sz="1300" b="1">
+                          <a:solidFill>
+                            <a:srgbClr val="1A1F27"/>
+                          </a:solidFill>
+                          <a:latin typeface="Segoe UI"/>
+                        </a:rPr>
+                        <a:t>Platform layer  (our approach)</a:t>
+                      </a:r>
+                    </a:p>
+                  </a:txBody>
+                  <a:tcPr anchor="ctr" marL="91440" marR="54864" marT="18288" marB="18288">
+                    <a:solidFill>
+                      <a:srgbClr val="F7F9F8"/>
+                    </a:solidFill>
+                  </a:tcPr>
+                </a:tc>
+                <a:tc>
+                  <a:txBody>
+                    <a:bodyPr wrap="square"/>
+                    <a:lstStyle/>
+                    <a:p>
+                      <a:r>
+                        <a:rPr sz="1300" b="0">
+                          <a:solidFill>
+                            <a:srgbClr val="535C6A"/>
+                          </a:solidFill>
+                          <a:latin typeface="Segoe UI"/>
+                        </a:rPr>
+                        <a:t>Build once; every use case inherits</a:t>
+                      </a:r>
+                    </a:p>
+                  </a:txBody>
+                  <a:tcPr anchor="ctr" marL="91440" marR="54864" marT="18288" marB="18288">
+                    <a:solidFill>
+                      <a:srgbClr val="F7F9F8"/>
+                    </a:solidFill>
+                  </a:tcPr>
+                </a:tc>
+                <a:tc>
+                  <a:txBody>
+                    <a:bodyPr wrap="square"/>
+                    <a:lstStyle/>
+                    <a:p>
+                      <a:r>
+                        <a:rPr sz="1300" b="0">
+                          <a:solidFill>
+                            <a:srgbClr val="535C6A"/>
+                          </a:solidFill>
+                          <a:latin typeface="Segoe UI"/>
+                        </a:rPr>
+                        <a:t>Fast · consistent · auditable</a:t>
+                      </a:r>
+                    </a:p>
+                  </a:txBody>
+                  <a:tcPr anchor="ctr" marL="91440" marR="54864" marT="18288" marB="18288">
+                    <a:solidFill>
+                      <a:srgbClr val="F7F9F8"/>
+                    </a:solidFill>
+                  </a:tcPr>
+                </a:tc>
+              </a:tr>
+            </a:tbl>
+          </a:graphicData>
+        </a:graphic>
+      </p:graphicFrame>
+      <p:sp>
+        <p:nvSpPr>
+          <p:cNvPr id="5" name="Rounded Rectangle 4"/>
+          <p:cNvSpPr/>
           <p:nvPr/>
         </p:nvSpPr>
         <p:spPr>
           <a:xfrm>
-            <a:off x="685800" y="1920240"/>
-            <a:ext cx="10881360" cy="4206240"/>
+            <a:off x="640080" y="3566160"/>
+            <a:ext cx="10927080" cy="914400"/>
           </a:xfrm>
-          <a:prstGeom prst="rect">
+          <a:prstGeom prst="roundRect">
             <a:avLst/>
           </a:prstGeom>
-          <a:noFill/>
+          <a:solidFill>
+            <a:srgbClr val="E1F0EE"/>
+          </a:solidFill>
+          <a:ln>
+            <a:noFill/>
+          </a:ln>
+          <a:effectLst/>
         </p:spPr>
-        <p:txBody>
-          <a:bodyPr wrap="square">
-            <a:spAutoFit/>
-          </a:bodyPr>
-          <a:lstStyle/>
+        <p:style>
+          <a:lnRef idx="1">
+            <a:schemeClr val="accent1"/>
+          </a:lnRef>
+          <a:fillRef idx="3">
+            <a:schemeClr val="accent1"/>
+          </a:fillRef>
+          <a:effectRef idx="2">
+            <a:schemeClr val="accent1"/>
+          </a:effectRef>
+          <a:fontRef idx="minor">
+            <a:schemeClr val="lt1"/>
+          </a:fontRef>
+        </p:style>
+        <p:txBody>
+          <a:bodyPr rtlCol="0" anchor="ctr" wrap="square" lIns="201168" rIns="201168"/>
+          <a:lstStyle/>
+          <a:p>
+            <a:pPr algn="ctr">
+              <a:spcAft>
+                <a:spcPts val="0"/>
+              </a:spcAft>
+            </a:pPr>
+            <a:r>
+              <a:rPr sz="1350" b="1">
+                <a:solidFill>
+                  <a:srgbClr val="0A5B55"/>
+                </a:solidFill>
+                <a:latin typeface="Segoe UI"/>
+              </a:rPr>
+              <a:t>The value compounds:  reduces risk (legal / reputational)   ·   builds client &amp; auditor confidence   ·   prepares for AI regulation   ·   differentiates every future use case.</a:t>
+            </a:r>
+          </a:p>
+        </p:txBody>
+      </p:sp>
+      <p:sp>
+        <p:nvSpPr>
+          <p:cNvPr id="6" name="Rounded Rectangle 5"/>
+          <p:cNvSpPr/>
+          <p:nvPr/>
+        </p:nvSpPr>
+        <p:spPr>
+          <a:xfrm>
+            <a:off x="640080" y="4709160"/>
+            <a:ext cx="10927080" cy="1417320"/>
+          </a:xfrm>
+          <a:prstGeom prst="roundRect">
+            <a:avLst/>
+          </a:prstGeom>
+          <a:solidFill>
+            <a:srgbClr val="E1F0EE"/>
+          </a:solidFill>
+          <a:ln w="9525">
+            <a:solidFill>
+              <a:srgbClr val="D9DFE5"/>
+            </a:solidFill>
+          </a:ln>
+          <a:effectLst/>
+        </p:spPr>
+        <p:style>
+          <a:lnRef idx="1">
+            <a:schemeClr val="accent1"/>
+          </a:lnRef>
+          <a:fillRef idx="3">
+            <a:schemeClr val="accent1"/>
+          </a:fillRef>
+          <a:effectRef idx="2">
+            <a:schemeClr val="accent1"/>
+          </a:effectRef>
+          <a:fontRef idx="minor">
+            <a:schemeClr val="lt1"/>
+          </a:fontRef>
+        </p:style>
+        <p:txBody>
+          <a:bodyPr rtlCol="0" anchor="ctr" wrap="square" lIns="146304" rIns="128016" tIns="118872" bIns="91440"/>
+          <a:lstStyle/>
+          <a:p>
+            <a:pPr algn="ctr">
+              <a:spcAft>
+                <a:spcPts val="700"/>
+              </a:spcAft>
+            </a:pPr>
+            <a:r>
+              <a:rPr sz="1250" b="1">
+                <a:solidFill>
+                  <a:srgbClr val="0E7C74"/>
+                </a:solidFill>
+                <a:latin typeface="Segoe UI"/>
+              </a:rPr>
+              <a:t>THE ONE MOVE THAT MATTERS MOST</a:t>
+            </a:r>
+          </a:p>
           <a:p>
             <a:pPr>
               <a:spcAft>
-                <a:spcPts val="1800"/>
+                <a:spcPts val="300"/>
               </a:spcAft>
             </a:pPr>
             <a:r>
-              <a:rPr sz="1800" b="0">
-                <a:solidFill>
-                  <a:srgbClr val="1A1F27"/>
+              <a:rPr sz="1150" b="0">
+                <a:solidFill>
+                  <a:srgbClr val="0A5B55"/>
                 </a:solidFill>
                 <a:latin typeface="Segoe UI"/>
               </a:rPr>
-              <a:t>Reduces risk — legal, reputational, and operational — by catching problems early.</a:t>
+              <a:t>The quality check the platform already runs before releasing a change becomes a quality-AND-responsibility check.</a:t>
             </a:r>
           </a:p>
           <a:p>
             <a:pPr>
               <a:spcAft>
-                <a:spcPts val="1800"/>
+                <a:spcPts val="300"/>
               </a:spcAft>
             </a:pPr>
             <a:r>
-              <a:rPr sz="1800" b="0">
-                <a:solidFill>
-                  <a:srgbClr val="1A1F27"/>
+              <a:rPr sz="1150" b="0">
+                <a:solidFill>
+                  <a:srgbClr val="535C6A"/>
                 </a:solidFill>
                 <a:latin typeface="Segoe UI"/>
               </a:rPr>
-              <a:t>Builds confidence with clients, auditors, and regulators, because decisions can be explained.</a:t>
-            </a:r>
-          </a:p>
-          <a:p>
-            <a:pPr>
-              <a:spcAft>
-                <a:spcPts val="1800"/>
-              </a:spcAft>
-            </a:pPr>
-            <a:r>
-              <a:rPr sz="1800" b="0">
-                <a:solidFill>
-                  <a:srgbClr val="1A1F27"/>
-                </a:solidFill>
-                <a:latin typeface="Segoe UI"/>
-              </a:rPr>
-              <a:t>Prepares for regulation — rules for AI that affects people are tightening.</a:t>
-            </a:r>
-          </a:p>
-          <a:p>
-            <a:pPr>
-              <a:spcAft>
-                <a:spcPts val="1800"/>
-              </a:spcAft>
-            </a:pPr>
-            <a:r>
-              <a:rPr sz="1800" b="0">
-                <a:solidFill>
-                  <a:srgbClr val="1A1F27"/>
-                </a:solidFill>
-                <a:latin typeface="Segoe UI"/>
-              </a:rPr>
-              <a:t>Differentiates us — a trusted, governed platform is easier to sell, expand, and keep.</a:t>
+              <a:t>Same mechanism, wider protection — and it applies to every use case at once.</a:t>
             </a:r>
           </a:p>
         </p:txBody>
@@ -4236,6 +4950,7 @@
           <a:ln>
             <a:noFill/>
           </a:ln>
+          <a:effectLst/>
         </p:spPr>
         <p:style>
           <a:lnRef idx="1">
@@ -4267,8 +4982,8 @@
         </p:nvSpPr>
         <p:spPr>
           <a:xfrm>
-            <a:off x="640080" y="384048"/>
-            <a:ext cx="11155680" cy="1280160"/>
+            <a:off x="640080" y="365760"/>
+            <a:ext cx="11247120" cy="1234440"/>
           </a:xfrm>
           <a:prstGeom prst="rect">
             <a:avLst/>
@@ -4283,17 +4998,17 @@
           <a:p>
             <a:pPr>
               <a:spcAft>
-                <a:spcPts val="500"/>
+                <a:spcPts val="400"/>
               </a:spcAft>
             </a:pPr>
             <a:r>
-              <a:rPr sz="1250" b="1">
+              <a:rPr sz="1200" b="1">
                 <a:solidFill>
                   <a:srgbClr val="0E7C74"/>
                 </a:solidFill>
                 <a:latin typeface="Segoe UI"/>
               </a:rPr>
-              <a:t>4 · THE FIT</a:t>
+              <a:t>HOW IT FITS</a:t>
             </a:r>
           </a:p>
           <a:p>
@@ -4303,13 +5018,13 @@
               </a:spcAft>
             </a:pPr>
             <a:r>
-              <a:rPr sz="2700" b="1">
+              <a:rPr sz="2500" b="1">
                 <a:solidFill>
                   <a:srgbClr val="1A1F27"/>
                 </a:solidFill>
                 <a:latin typeface="Segoe UI"/>
               </a:rPr>
-              <a:t>How it fits the platform we already run</a:t>
+              <a:t>It extends the platform capabilities we already run</a:t>
             </a:r>
           </a:p>
         </p:txBody>
@@ -4323,8 +5038,8 @@
           <p:nvPr/>
         </p:nvGraphicFramePr>
         <p:xfrm>
-          <a:off x="640080" y="1783080"/>
-          <a:ext cx="10927080" cy="3520440"/>
+          <a:off x="640080" y="1828800"/>
+          <a:ext cx="10927080" cy="3968496"/>
         </p:xfrm>
         <a:graphic>
           <a:graphicData uri="http://schemas.openxmlformats.org/drawingml/2006/table">
@@ -4333,27 +5048,28 @@
                 <a:tableStyleId>{5C22544A-7EE6-4342-B048-85BDC9FD1C3A}</a:tableStyleId>
               </a:tblPr>
               <a:tblGrid>
-                <a:gridCol w="3108960"/>
-                <a:gridCol w="7818120"/>
+                <a:gridCol w="2651760"/>
+                <a:gridCol w="3200400"/>
+                <a:gridCol w="5074920"/>
               </a:tblGrid>
-              <a:tr h="502920">
+              <a:tr h="566928">
                 <a:tc>
                   <a:txBody>
                     <a:bodyPr wrap="square"/>
                     <a:lstStyle/>
                     <a:p>
                       <a:r>
-                        <a:rPr sz="1150" b="1">
+                        <a:rPr sz="1100" b="1">
                           <a:solidFill>
                             <a:srgbClr val="FFFFFF"/>
                           </a:solidFill>
                           <a:latin typeface="Segoe UI"/>
                         </a:rPr>
-                        <a:t>What we run today</a:t>
+                        <a:t>Platform capability</a:t>
                       </a:r>
                     </a:p>
                   </a:txBody>
-                  <a:tcPr anchor="ctr" marL="91440" marR="54864" marT="27432" marB="27432">
+                  <a:tcPr anchor="ctr" marL="91440" marR="54864" marT="18288" marB="18288">
                     <a:solidFill>
                       <a:srgbClr val="0E7C74"/>
                     </a:solidFill>
@@ -4365,7 +5081,29 @@
                     <a:lstStyle/>
                     <a:p>
                       <a:r>
-                        <a:rPr sz="1150" b="1">
+                        <a:rPr sz="1100" b="1">
+                          <a:solidFill>
+                            <a:srgbClr val="FFFFFF"/>
+                          </a:solidFill>
+                          <a:latin typeface="Segoe UI"/>
+                        </a:rPr>
+                        <a:t>What it does today</a:t>
+                      </a:r>
+                    </a:p>
+                  </a:txBody>
+                  <a:tcPr anchor="ctr" marL="91440" marR="54864" marT="18288" marB="18288">
+                    <a:solidFill>
+                      <a:srgbClr val="0E7C74"/>
+                    </a:solidFill>
+                  </a:tcPr>
+                </a:tc>
+                <a:tc>
+                  <a:txBody>
+                    <a:bodyPr wrap="square"/>
+                    <a:lstStyle/>
+                    <a:p>
+                      <a:r>
+                        <a:rPr sz="1100" b="1">
                           <a:solidFill>
                             <a:srgbClr val="FFFFFF"/>
                           </a:solidFill>
@@ -4375,21 +5113,21 @@
                       </a:r>
                     </a:p>
                   </a:txBody>
-                  <a:tcPr anchor="ctr" marL="91440" marR="54864" marT="27432" marB="27432">
+                  <a:tcPr anchor="ctr" marL="91440" marR="54864" marT="18288" marB="18288">
                     <a:solidFill>
                       <a:srgbClr val="0E7C74"/>
                     </a:solidFill>
                   </a:tcPr>
                 </a:tc>
               </a:tr>
-              <a:tr h="502920">
+              <a:tr h="566928">
                 <a:tc>
                   <a:txBody>
                     <a:bodyPr wrap="square"/>
                     <a:lstStyle/>
                     <a:p>
                       <a:r>
-                        <a:rPr sz="1350" b="1">
+                        <a:rPr sz="1200" b="1">
                           <a:solidFill>
                             <a:srgbClr val="1A1F27"/>
                           </a:solidFill>
@@ -4399,7 +5137,7 @@
                       </a:r>
                     </a:p>
                   </a:txBody>
-                  <a:tcPr anchor="ctr" marL="91440" marR="54864" marT="27432" marB="27432">
+                  <a:tcPr anchor="ctr" marL="91440" marR="54864" marT="18288" marB="18288">
                     <a:solidFill>
                       <a:srgbClr val="FFFFFF"/>
                     </a:solidFill>
@@ -4411,31 +5149,53 @@
                     <a:lstStyle/>
                     <a:p>
                       <a:r>
-                        <a:rPr sz="1350" b="0">
+                        <a:rPr sz="1200" b="0">
                           <a:solidFill>
                             <a:srgbClr val="535C6A"/>
                           </a:solidFill>
                           <a:latin typeface="Segoe UI"/>
                         </a:rPr>
-                        <a:t>Also check fairness, safety, and evidence — and block a change that fails</a:t>
+                        <a:t>Scores quality before release</a:t>
                       </a:r>
                     </a:p>
                   </a:txBody>
-                  <a:tcPr anchor="ctr" marL="91440" marR="54864" marT="27432" marB="27432">
+                  <a:tcPr anchor="ctr" marL="91440" marR="54864" marT="18288" marB="18288">
+                    <a:solidFill>
+                      <a:srgbClr val="FFFFFF"/>
+                    </a:solidFill>
+                  </a:tcPr>
+                </a:tc>
+                <a:tc>
+                  <a:txBody>
+                    <a:bodyPr wrap="square"/>
+                    <a:lstStyle/>
+                    <a:p>
+                      <a:r>
+                        <a:rPr sz="1200" b="0">
+                          <a:solidFill>
+                            <a:srgbClr val="535C6A"/>
+                          </a:solidFill>
+                          <a:latin typeface="Segoe UI"/>
+                        </a:rPr>
+                        <a:t>Also checks fairness, safety, evidence — blocks failures</a:t>
+                      </a:r>
+                    </a:p>
+                  </a:txBody>
+                  <a:tcPr anchor="ctr" marL="91440" marR="54864" marT="18288" marB="18288">
                     <a:solidFill>
                       <a:srgbClr val="FFFFFF"/>
                     </a:solidFill>
                   </a:tcPr>
                 </a:tc>
               </a:tr>
-              <a:tr h="502920">
+              <a:tr h="566928">
                 <a:tc>
                   <a:txBody>
                     <a:bodyPr wrap="square"/>
                     <a:lstStyle/>
                     <a:p>
                       <a:r>
-                        <a:rPr sz="1350" b="1">
+                        <a:rPr sz="1200" b="1">
                           <a:solidFill>
                             <a:srgbClr val="1A1F27"/>
                           </a:solidFill>
@@ -4445,7 +5205,7 @@
                       </a:r>
                     </a:p>
                   </a:txBody>
-                  <a:tcPr anchor="ctr" marL="91440" marR="54864" marT="27432" marB="27432">
+                  <a:tcPr anchor="ctr" marL="91440" marR="54864" marT="18288" marB="18288">
                     <a:solidFill>
                       <a:srgbClr val="F7F9F8"/>
                     </a:solidFill>
@@ -4457,31 +5217,53 @@
                     <a:lstStyle/>
                     <a:p>
                       <a:r>
-                        <a:rPr sz="1350" b="0">
+                        <a:rPr sz="1200" b="0">
                           <a:solidFill>
                             <a:srgbClr val="535C6A"/>
                           </a:solidFill>
                           <a:latin typeface="Segoe UI"/>
                         </a:rPr>
-                        <a:t>Add checks for unsafe or inappropriate content, plus an audit record</a:t>
+                        <a:t>Detects sensitive data (PII)</a:t>
                       </a:r>
                     </a:p>
                   </a:txBody>
-                  <a:tcPr anchor="ctr" marL="91440" marR="54864" marT="27432" marB="27432">
+                  <a:tcPr anchor="ctr" marL="91440" marR="54864" marT="18288" marB="18288">
+                    <a:solidFill>
+                      <a:srgbClr val="F7F9F8"/>
+                    </a:solidFill>
+                  </a:tcPr>
+                </a:tc>
+                <a:tc>
+                  <a:txBody>
+                    <a:bodyPr wrap="square"/>
+                    <a:lstStyle/>
+                    <a:p>
+                      <a:r>
+                        <a:rPr sz="1200" b="0">
+                          <a:solidFill>
+                            <a:srgbClr val="535C6A"/>
+                          </a:solidFill>
+                          <a:latin typeface="Segoe UI"/>
+                        </a:rPr>
+                        <a:t>Adds unsafe-content checks + an audit record</a:t>
+                      </a:r>
+                    </a:p>
+                  </a:txBody>
+                  <a:tcPr anchor="ctr" marL="91440" marR="54864" marT="18288" marB="18288">
                     <a:solidFill>
                       <a:srgbClr val="F7F9F8"/>
                     </a:solidFill>
                   </a:tcPr>
                 </a:tc>
               </a:tr>
-              <a:tr h="502920">
+              <a:tr h="566928">
                 <a:tc>
                   <a:txBody>
                     <a:bodyPr wrap="square"/>
                     <a:lstStyle/>
                     <a:p>
                       <a:r>
-                        <a:rPr sz="1350" b="1">
+                        <a:rPr sz="1200" b="1">
                           <a:solidFill>
                             <a:srgbClr val="1A1F27"/>
                           </a:solidFill>
@@ -4491,7 +5273,7 @@
                       </a:r>
                     </a:p>
                   </a:txBody>
-                  <a:tcPr anchor="ctr" marL="91440" marR="54864" marT="27432" marB="27432">
+                  <a:tcPr anchor="ctr" marL="91440" marR="54864" marT="18288" marB="18288">
                     <a:solidFill>
                       <a:srgbClr val="FFFFFF"/>
                     </a:solidFill>
@@ -4503,31 +5285,53 @@
                     <a:lstStyle/>
                     <a:p>
                       <a:r>
-                        <a:rPr sz="1350" b="0">
+                        <a:rPr sz="1200" b="0">
                           <a:solidFill>
                             <a:srgbClr val="535C6A"/>
                           </a:solidFill>
                           <a:latin typeface="Segoe UI"/>
                         </a:rPr>
-                        <a:t>Also track fairness and unusual behaviour over time</a:t>
+                        <a:t>Tracks cost, speed, errors</a:t>
                       </a:r>
                     </a:p>
                   </a:txBody>
-                  <a:tcPr anchor="ctr" marL="91440" marR="54864" marT="27432" marB="27432">
+                  <a:tcPr anchor="ctr" marL="91440" marR="54864" marT="18288" marB="18288">
+                    <a:solidFill>
+                      <a:srgbClr val="FFFFFF"/>
+                    </a:solidFill>
+                  </a:tcPr>
+                </a:tc>
+                <a:tc>
+                  <a:txBody>
+                    <a:bodyPr wrap="square"/>
+                    <a:lstStyle/>
+                    <a:p>
+                      <a:r>
+                        <a:rPr sz="1200" b="0">
+                          <a:solidFill>
+                            <a:srgbClr val="535C6A"/>
+                          </a:solidFill>
+                          <a:latin typeface="Segoe UI"/>
+                        </a:rPr>
+                        <a:t>Also tracks fairness &amp; unusual behaviour</a:t>
+                      </a:r>
+                    </a:p>
+                  </a:txBody>
+                  <a:tcPr anchor="ctr" marL="91440" marR="54864" marT="18288" marB="18288">
                     <a:solidFill>
                       <a:srgbClr val="FFFFFF"/>
                     </a:solidFill>
                   </a:tcPr>
                 </a:tc>
               </a:tr>
-              <a:tr h="502920">
+              <a:tr h="566928">
                 <a:tc>
                   <a:txBody>
                     <a:bodyPr wrap="square"/>
                     <a:lstStyle/>
                     <a:p>
                       <a:r>
-                        <a:rPr sz="1350" b="1">
+                        <a:rPr sz="1200" b="1">
                           <a:solidFill>
                             <a:srgbClr val="1A1F27"/>
                           </a:solidFill>
@@ -4537,7 +5341,7 @@
                       </a:r>
                     </a:p>
                   </a:txBody>
-                  <a:tcPr anchor="ctr" marL="91440" marR="54864" marT="27432" marB="27432">
+                  <a:tcPr anchor="ctr" marL="91440" marR="54864" marT="18288" marB="18288">
                     <a:solidFill>
                       <a:srgbClr val="F7F9F8"/>
                     </a:solidFill>
@@ -4549,41 +5353,63 @@
                     <a:lstStyle/>
                     <a:p>
                       <a:r>
-                        <a:rPr sz="1350" b="0">
+                        <a:rPr sz="1200" b="0">
                           <a:solidFill>
                             <a:srgbClr val="535C6A"/>
                           </a:solidFill>
                           <a:latin typeface="Segoe UI"/>
                         </a:rPr>
-                        <a:t>Becomes a way to report and challenge a result</a:t>
+                        <a:t>Users rate results</a:t>
                       </a:r>
                     </a:p>
                   </a:txBody>
-                  <a:tcPr anchor="ctr" marL="91440" marR="54864" marT="27432" marB="27432">
+                  <a:tcPr anchor="ctr" marL="91440" marR="54864" marT="18288" marB="18288">
+                    <a:solidFill>
+                      <a:srgbClr val="F7F9F8"/>
+                    </a:solidFill>
+                  </a:tcPr>
+                </a:tc>
+                <a:tc>
+                  <a:txBody>
+                    <a:bodyPr wrap="square"/>
+                    <a:lstStyle/>
+                    <a:p>
+                      <a:r>
+                        <a:rPr sz="1200" b="0">
+                          <a:solidFill>
+                            <a:srgbClr val="535C6A"/>
+                          </a:solidFill>
+                          <a:latin typeface="Segoe UI"/>
+                        </a:rPr>
+                        <a:t>Becomes a way to report &amp; challenge a result</a:t>
+                      </a:r>
+                    </a:p>
+                  </a:txBody>
+                  <a:tcPr anchor="ctr" marL="91440" marR="54864" marT="18288" marB="18288">
                     <a:solidFill>
                       <a:srgbClr val="F7F9F8"/>
                     </a:solidFill>
                   </a:tcPr>
                 </a:tc>
               </a:tr>
-              <a:tr h="502920">
+              <a:tr h="566928">
                 <a:tc>
                   <a:txBody>
                     <a:bodyPr wrap="square"/>
                     <a:lstStyle/>
                     <a:p>
                       <a:r>
-                        <a:rPr sz="1350" b="1">
+                        <a:rPr sz="1200" b="1">
                           <a:solidFill>
                             <a:srgbClr val="1A1F27"/>
                           </a:solidFill>
                           <a:latin typeface="Segoe UI"/>
                         </a:rPr>
-                        <a:t>Model &amp; prompt management</a:t>
+                        <a:t>Model &amp; prompt mgmt</a:t>
                       </a:r>
                     </a:p>
                   </a:txBody>
-                  <a:tcPr anchor="ctr" marL="91440" marR="54864" marT="27432" marB="27432">
+                  <a:tcPr anchor="ctr" marL="91440" marR="54864" marT="18288" marB="18288">
                     <a:solidFill>
                       <a:srgbClr val="FFFFFF"/>
                     </a:solidFill>
@@ -4595,31 +5421,53 @@
                     <a:lstStyle/>
                     <a:p>
                       <a:r>
-                        <a:rPr sz="1350" b="0">
+                        <a:rPr sz="1200" b="0">
                           <a:solidFill>
                             <a:srgbClr val="535C6A"/>
                           </a:solidFill>
                           <a:latin typeface="Segoe UI"/>
                         </a:rPr>
-                        <a:t>Record each model's intended use and known limits</a:t>
+                        <a:t>Manages versions</a:t>
                       </a:r>
                     </a:p>
                   </a:txBody>
-                  <a:tcPr anchor="ctr" marL="91440" marR="54864" marT="27432" marB="27432">
+                  <a:tcPr anchor="ctr" marL="91440" marR="54864" marT="18288" marB="18288">
+                    <a:solidFill>
+                      <a:srgbClr val="FFFFFF"/>
+                    </a:solidFill>
+                  </a:tcPr>
+                </a:tc>
+                <a:tc>
+                  <a:txBody>
+                    <a:bodyPr wrap="square"/>
+                    <a:lstStyle/>
+                    <a:p>
+                      <a:r>
+                        <a:rPr sz="1200" b="0">
+                          <a:solidFill>
+                            <a:srgbClr val="535C6A"/>
+                          </a:solidFill>
+                          <a:latin typeface="Segoe UI"/>
+                        </a:rPr>
+                        <a:t>Records intended use &amp; known limits (model cards)</a:t>
+                      </a:r>
+                    </a:p>
+                  </a:txBody>
+                  <a:tcPr anchor="ctr" marL="91440" marR="54864" marT="18288" marB="18288">
                     <a:solidFill>
                       <a:srgbClr val="FFFFFF"/>
                     </a:solidFill>
                   </a:tcPr>
                 </a:tc>
               </a:tr>
-              <a:tr h="502920">
+              <a:tr h="566928">
                 <a:tc>
                   <a:txBody>
                     <a:bodyPr wrap="square"/>
                     <a:lstStyle/>
                     <a:p>
                       <a:r>
-                        <a:rPr sz="1350" b="1">
+                        <a:rPr sz="1200" b="1">
                           <a:solidFill>
                             <a:srgbClr val="1A1F27"/>
                           </a:solidFill>
@@ -4629,7 +5477,7 @@
                       </a:r>
                     </a:p>
                   </a:txBody>
-                  <a:tcPr anchor="ctr" marL="91440" marR="54864" marT="27432" marB="27432">
+                  <a:tcPr anchor="ctr" marL="91440" marR="54864" marT="18288" marB="18288">
                     <a:solidFill>
                       <a:srgbClr val="F7F9F8"/>
                     </a:solidFill>
@@ -4641,17 +5489,39 @@
                     <a:lstStyle/>
                     <a:p>
                       <a:r>
-                        <a:rPr sz="1350" b="0">
+                        <a:rPr sz="1200" b="0">
                           <a:solidFill>
                             <a:srgbClr val="535C6A"/>
                           </a:solidFill>
                           <a:latin typeface="Segoe UI"/>
                         </a:rPr>
-                        <a:t>Keep a person in the loop and a way to switch off a bad model</a:t>
+                        <a:t>Rate limits, retries</a:t>
                       </a:r>
                     </a:p>
                   </a:txBody>
-                  <a:tcPr anchor="ctr" marL="91440" marR="54864" marT="27432" marB="27432">
+                  <a:tcPr anchor="ctr" marL="91440" marR="54864" marT="18288" marB="18288">
+                    <a:solidFill>
+                      <a:srgbClr val="F7F9F8"/>
+                    </a:solidFill>
+                  </a:tcPr>
+                </a:tc>
+                <a:tc>
+                  <a:txBody>
+                    <a:bodyPr wrap="square"/>
+                    <a:lstStyle/>
+                    <a:p>
+                      <a:r>
+                        <a:rPr sz="1200" b="0">
+                          <a:solidFill>
+                            <a:srgbClr val="535C6A"/>
+                          </a:solidFill>
+                          <a:latin typeface="Segoe UI"/>
+                        </a:rPr>
+                        <a:t>Human-in-the-loop + a switch to stop a bad model</a:t>
+                      </a:r>
+                    </a:p>
+                  </a:txBody>
+                  <a:tcPr anchor="ctr" marL="91440" marR="54864" marT="18288" marB="18288">
                     <a:solidFill>
                       <a:srgbClr val="F7F9F8"/>
                     </a:solidFill>
@@ -4662,62 +5532,6 @@
           </a:graphicData>
         </a:graphic>
       </p:graphicFrame>
-      <p:sp>
-        <p:nvSpPr>
-          <p:cNvPr id="5" name="Rectangle 4"/>
-          <p:cNvSpPr/>
-          <p:nvPr/>
-        </p:nvSpPr>
-        <p:spPr>
-          <a:xfrm>
-            <a:off x="685800" y="5806440"/>
-            <a:ext cx="10881360" cy="777240"/>
-          </a:xfrm>
-          <a:prstGeom prst="rect">
-            <a:avLst/>
-          </a:prstGeom>
-          <a:solidFill>
-            <a:srgbClr val="F2F5F4"/>
-          </a:solidFill>
-          <a:ln>
-            <a:noFill/>
-          </a:ln>
-        </p:spPr>
-        <p:style>
-          <a:lnRef idx="1">
-            <a:schemeClr val="accent1"/>
-          </a:lnRef>
-          <a:fillRef idx="3">
-            <a:schemeClr val="accent1"/>
-          </a:fillRef>
-          <a:effectRef idx="2">
-            <a:schemeClr val="accent1"/>
-          </a:effectRef>
-          <a:fontRef idx="minor">
-            <a:schemeClr val="lt1"/>
-          </a:fontRef>
-        </p:style>
-        <p:txBody>
-          <a:bodyPr rtlCol="0" anchor="ctr" wrap="square" lIns="228600" rIns="228600"/>
-          <a:lstStyle/>
-          <a:p>
-            <a:pPr algn="ctr">
-              <a:spcAft>
-                <a:spcPts val="0"/>
-              </a:spcAft>
-            </a:pPr>
-            <a:r>
-              <a:rPr sz="1600" b="1">
-                <a:solidFill>
-                  <a:srgbClr val="0E7C74"/>
-                </a:solidFill>
-                <a:latin typeface="Segoe UI"/>
-              </a:rPr>
-              <a:t>The check we already run before release becomes a quality-and-responsibility check — same mechanism, wider protection.</a:t>
-            </a:r>
-          </a:p>
-        </p:txBody>
-      </p:sp>
     </p:spTree>
   </p:cSld>
   <p:clrMapOvr>
@@ -4764,6 +5578,7 @@
           <a:ln>
             <a:noFill/>
           </a:ln>
+          <a:effectLst/>
         </p:spPr>
         <p:style>
           <a:lnRef idx="1">
@@ -4795,8 +5610,8 @@
         </p:nvSpPr>
         <p:spPr>
           <a:xfrm>
-            <a:off x="640080" y="384048"/>
-            <a:ext cx="11155680" cy="1280160"/>
+            <a:off x="640080" y="365760"/>
+            <a:ext cx="11247120" cy="1234440"/>
           </a:xfrm>
           <a:prstGeom prst="rect">
             <a:avLst/>
@@ -4811,17 +5626,17 @@
           <a:p>
             <a:pPr>
               <a:spcAft>
-                <a:spcPts val="500"/>
+                <a:spcPts val="400"/>
               </a:spcAft>
             </a:pPr>
             <a:r>
-              <a:rPr sz="1250" b="1">
+              <a:rPr sz="1200" b="1">
                 <a:solidFill>
                   <a:srgbClr val="0E7C74"/>
                 </a:solidFill>
                 <a:latin typeface="Segoe UI"/>
               </a:rPr>
-              <a:t>5 · APIX</a:t>
+              <a:t>EXAMPLE USE CASE · APIX</a:t>
             </a:r>
           </a:p>
           <a:p>
@@ -4831,13 +5646,13 @@
               </a:spcAft>
             </a:pPr>
             <a:r>
-              <a:rPr sz="2700" b="1">
+              <a:rPr sz="2500" b="1">
                 <a:solidFill>
                   <a:srgbClr val="1A1F27"/>
                 </a:solidFill>
                 <a:latin typeface="Segoe UI"/>
               </a:rPr>
-              <a:t>Why it matters even more for APIX</a:t>
+              <a:t>Why it matters most where AI scores people</a:t>
             </a:r>
           </a:p>
         </p:txBody>
@@ -4850,7 +5665,7 @@
         </p:nvSpPr>
         <p:spPr>
           <a:xfrm>
-            <a:off x="685800" y="1600200"/>
+            <a:off x="685800" y="1554480"/>
             <a:ext cx="10881360" cy="548640"/>
           </a:xfrm>
           <a:prstGeom prst="rect">
@@ -4870,13 +5685,13 @@
               </a:spcAft>
             </a:pPr>
             <a:r>
-              <a:rPr sz="1500" b="0">
+              <a:rPr sz="1400" b="0">
                 <a:solidFill>
                   <a:srgbClr val="535C6A"/>
                 </a:solidFill>
                 <a:latin typeface="Segoe UI"/>
               </a:rPr>
-              <a:t>APIX scores agents — it evaluates people's work. And it is already well suited to Responsible AI:</a:t>
+              <a:t>APIX uses AI to help evaluate agents' work — a high-stakes case. It is also already well suited to Responsible AI:</a:t>
             </a:r>
           </a:p>
         </p:txBody>
@@ -4889,8 +5704,8 @@
         </p:nvSpPr>
         <p:spPr>
           <a:xfrm>
-            <a:off x="685800" y="2240280"/>
-            <a:ext cx="10881360" cy="2834640"/>
+            <a:off x="685800" y="2148840"/>
+            <a:ext cx="10881360" cy="4023360"/>
           </a:xfrm>
           <a:prstGeom prst="rect">
             <a:avLst/>
@@ -4905,105 +5720,106 @@
           <a:p>
             <a:pPr>
               <a:spcAft>
-                <a:spcPts val="1200"/>
+                <a:spcPts val="1300"/>
               </a:spcAft>
             </a:pPr>
             <a:r>
-              <a:rPr sz="1550" b="0">
+              <a:rPr sz="1500" b="0">
                 <a:solidFill>
                   <a:srgbClr val="1A1F27"/>
                 </a:solidFill>
                 <a:latin typeface="Segoe UI"/>
               </a:rPr>
-              <a:t>Fairness — check that scores don't disadvantage any group (e.g. non-native English speakers).</a:t>
+              <a:t>Fairness — check scores don't disadvantage any group (e.g. non-native speakers)</a:t>
             </a:r>
           </a:p>
           <a:p>
             <a:pPr>
               <a:spcAft>
-                <a:spcPts val="1200"/>
+                <a:spcPts val="1300"/>
               </a:spcAft>
             </a:pPr>
             <a:r>
-              <a:rPr sz="1550" b="0">
+              <a:rPr sz="1500" b="0">
                 <a:solidFill>
                   <a:srgbClr val="1A1F27"/>
                 </a:solidFill>
                 <a:latin typeface="Segoe UI"/>
               </a:rPr>
-              <a:t>Transparency — every score already has the exact call moments behind it; agents can see and question it.</a:t>
+              <a:t>Transparency — every score already carries the exact call moments behind it</a:t>
             </a:r>
           </a:p>
           <a:p>
             <a:pPr>
               <a:spcAft>
-                <a:spcPts val="1200"/>
+                <a:spcPts val="1300"/>
               </a:spcAft>
             </a:pPr>
             <a:r>
-              <a:rPr sz="1550" b="0">
+              <a:rPr sz="1500" b="0">
                 <a:solidFill>
                   <a:srgbClr val="1A1F27"/>
                 </a:solidFill>
                 <a:latin typeface="Segoe UI"/>
               </a:rPr>
-              <a:t>Human oversight — coaches review the output; the AI assists, it doesn't decide alone.</a:t>
+              <a:t>Human oversight — coaches review; the AI assists, it doesn't decide alone</a:t>
             </a:r>
           </a:p>
           <a:p>
             <a:pPr>
               <a:spcAft>
-                <a:spcPts val="1200"/>
+                <a:spcPts val="1300"/>
               </a:spcAft>
             </a:pPr>
             <a:r>
-              <a:rPr sz="1550" b="0">
+              <a:rPr sz="1500" b="0">
                 <a:solidFill>
                   <a:srgbClr val="1A1F27"/>
                 </a:solidFill>
                 <a:latin typeface="Segoe UI"/>
               </a:rPr>
-              <a:t>Privacy — customer details in call recordings are protected.</a:t>
+              <a:t>Privacy — customer details in recordings are protected</a:t>
             </a:r>
           </a:p>
           <a:p>
             <a:pPr>
               <a:spcAft>
-                <a:spcPts val="1200"/>
+                <a:spcPts val="1300"/>
               </a:spcAft>
             </a:pPr>
             <a:r>
-              <a:rPr sz="1550" b="0">
+              <a:rPr sz="1500" b="0">
                 <a:solidFill>
                   <a:srgbClr val="1A1F27"/>
                 </a:solidFill>
                 <a:latin typeface="Segoe UI"/>
               </a:rPr>
-              <a:t>Evidence-based coaching — backed by what happened on the call, never invented.</a:t>
-            </a:r>
-          </a:p>
-        </p:txBody>
-      </p:sp>
-      <p:sp>
-        <p:nvSpPr>
-          <p:cNvPr id="6" name="Rectangle 5"/>
+              <a:t>Evidence-based — coaching is tied to what actually happened on the call</a:t>
+            </a:r>
+          </a:p>
+        </p:txBody>
+      </p:sp>
+      <p:sp>
+        <p:nvSpPr>
+          <p:cNvPr id="6" name="Rounded Rectangle 5"/>
           <p:cNvSpPr/>
           <p:nvPr/>
         </p:nvSpPr>
         <p:spPr>
           <a:xfrm>
-            <a:off x="685800" y="5852160"/>
-            <a:ext cx="10881360" cy="731520"/>
+            <a:off x="640080" y="5486400"/>
+            <a:ext cx="10927080" cy="822960"/>
           </a:xfrm>
-          <a:prstGeom prst="rect">
+          <a:prstGeom prst="roundRect">
             <a:avLst/>
           </a:prstGeom>
           <a:solidFill>
-            <a:srgbClr val="F2F5F4"/>
+            <a:srgbClr val="E4F3EB"/>
           </a:solidFill>
           <a:ln>
             <a:noFill/>
           </a:ln>
+          <a:effectLst/>
         </p:spPr>
         <p:style>
           <a:lnRef idx="1">
@@ -5020,7 +5836,7 @@
           </a:fontRef>
         </p:style>
         <p:txBody>
-          <a:bodyPr rtlCol="0" anchor="ctr" wrap="square" lIns="228600" rIns="228600"/>
+          <a:bodyPr rtlCol="0" anchor="ctr" wrap="square" lIns="201168" rIns="201168"/>
           <a:lstStyle/>
           <a:p>
             <a:pPr algn="ctr">
@@ -5029,13 +5845,13 @@
               </a:spcAft>
             </a:pPr>
             <a:r>
-              <a:rPr sz="1600" b="1">
-                <a:solidFill>
-                  <a:srgbClr val="0E7C74"/>
+              <a:rPr sz="1400" b="1">
+                <a:solidFill>
+                  <a:srgbClr val="2E8B5E"/>
                 </a:solidFill>
                 <a:latin typeface="Segoe UI"/>
               </a:rPr>
-              <a:t>APIX already keeps the evidence and keeps coaches in the loop — Responsible AI in practice, not on paper.</a:t>
+              <a:t>Because APIX already keeps the evidence and keeps coaches in the loop, it shows Responsible AI in practice — a template the next use case reuses.</a:t>
             </a:r>
           </a:p>
         </p:txBody>
@@ -5086,6 +5902,7 @@
           <a:ln>
             <a:noFill/>
           </a:ln>
+          <a:effectLst/>
         </p:spPr>
         <p:style>
           <a:lnRef idx="1">
@@ -5117,8 +5934,8 @@
         </p:nvSpPr>
         <p:spPr>
           <a:xfrm>
-            <a:off x="640080" y="384048"/>
-            <a:ext cx="11155680" cy="1280160"/>
+            <a:off x="640080" y="365760"/>
+            <a:ext cx="11247120" cy="1234440"/>
           </a:xfrm>
           <a:prstGeom prst="rect">
             <a:avLst/>
@@ -5133,17 +5950,17 @@
           <a:p>
             <a:pPr>
               <a:spcAft>
-                <a:spcPts val="500"/>
+                <a:spcPts val="400"/>
               </a:spcAft>
             </a:pPr>
             <a:r>
-              <a:rPr sz="1250" b="1">
+              <a:rPr sz="1200" b="1">
                 <a:solidFill>
                   <a:srgbClr val="0E7C74"/>
                 </a:solidFill>
                 <a:latin typeface="Segoe UI"/>
               </a:rPr>
-              <a:t>6 · THE PATH</a:t>
+              <a:t>WORKED EXAMPLES</a:t>
             </a:r>
           </a:p>
           <a:p>
@@ -5153,110 +5970,146 @@
               </a:spcAft>
             </a:pPr>
             <a:r>
-              <a:rPr sz="2700" b="1">
+              <a:rPr sz="2500" b="1">
                 <a:solidFill>
                   <a:srgbClr val="1A1F27"/>
                 </a:solidFill>
                 <a:latin typeface="Segoe UI"/>
               </a:rPr>
-              <a:t>Where we are, and the next steps</a:t>
-            </a:r>
-          </a:p>
-        </p:txBody>
-      </p:sp>
-      <p:sp>
-        <p:nvSpPr>
-          <p:cNvPr id="4" name="TextBox 3"/>
-          <p:cNvSpPr txBox="1"/>
+              <a:t>Fairness and transparency, made concrete</a:t>
+            </a:r>
+          </a:p>
+        </p:txBody>
+      </p:sp>
+      <p:sp>
+        <p:nvSpPr>
+          <p:cNvPr id="4" name="Rounded Rectangle 3"/>
+          <p:cNvSpPr/>
           <p:nvPr/>
         </p:nvSpPr>
         <p:spPr>
           <a:xfrm>
-            <a:off x="685800" y="1920240"/>
-            <a:ext cx="10881360" cy="4206240"/>
+            <a:off x="640080" y="1828800"/>
+            <a:ext cx="5486400" cy="3657600"/>
           </a:xfrm>
-          <a:prstGeom prst="rect">
+          <a:prstGeom prst="roundRect">
             <a:avLst/>
           </a:prstGeom>
-          <a:noFill/>
+          <a:solidFill>
+            <a:srgbClr val="E1F0EE"/>
+          </a:solidFill>
+          <a:ln w="9525">
+            <a:solidFill>
+              <a:srgbClr val="D9DFE5"/>
+            </a:solidFill>
+          </a:ln>
+          <a:effectLst/>
         </p:spPr>
-        <p:txBody>
-          <a:bodyPr wrap="square">
-            <a:spAutoFit/>
-          </a:bodyPr>
-          <a:lstStyle/>
+        <p:style>
+          <a:lnRef idx="1">
+            <a:schemeClr val="accent1"/>
+          </a:lnRef>
+          <a:fillRef idx="3">
+            <a:schemeClr val="accent1"/>
+          </a:fillRef>
+          <a:effectRef idx="2">
+            <a:schemeClr val="accent1"/>
+          </a:effectRef>
+          <a:fontRef idx="minor">
+            <a:schemeClr val="lt1"/>
+          </a:fontRef>
+        </p:style>
+        <p:txBody>
+          <a:bodyPr rtlCol="0" anchor="ctr" wrap="square" lIns="146304" rIns="128016" tIns="118872" bIns="91440"/>
+          <a:lstStyle/>
+          <a:p>
+            <a:pPr algn="ctr">
+              <a:spcAft>
+                <a:spcPts val="700"/>
+              </a:spcAft>
+            </a:pPr>
+            <a:r>
+              <a:rPr sz="1250" b="1">
+                <a:solidFill>
+                  <a:srgbClr val="0E7C74"/>
+                </a:solidFill>
+                <a:latin typeface="Segoe UI"/>
+              </a:rPr>
+              <a:t>FAIRNESS CHECK · language-proficiency score</a:t>
+            </a:r>
+          </a:p>
           <a:p>
             <a:pPr>
               <a:spcAft>
-                <a:spcPts val="1500"/>
+                <a:spcPts val="300"/>
               </a:spcAft>
             </a:pPr>
             <a:r>
-              <a:rPr sz="1800" b="0">
-                <a:solidFill>
-                  <a:srgbClr val="1A1F27"/>
+              <a:rPr sz="1150" b="0">
+                <a:solidFill>
+                  <a:srgbClr val="535C6A"/>
                 </a:solidFill>
                 <a:latin typeface="Segoe UI"/>
               </a:rPr>
-              <a:t>1.   Check APIX scores for fairness across groups of agents.</a:t>
+              <a:t>Compare average scores by group:</a:t>
             </a:r>
           </a:p>
           <a:p>
             <a:pPr>
               <a:spcAft>
-                <a:spcPts val="1500"/>
+                <a:spcPts val="300"/>
               </a:spcAft>
             </a:pPr>
             <a:r>
-              <a:rPr sz="1800" b="0">
-                <a:solidFill>
-                  <a:srgbClr val="1A1F27"/>
-                </a:solidFill>
-                <a:latin typeface="Segoe UI"/>
+              <a:rPr sz="1150" b="0">
+                <a:solidFill>
+                  <a:srgbClr val="0A5B55"/>
+                </a:solidFill>
+                <a:latin typeface="Consolas"/>
               </a:rPr>
-              <a:t>2.   Add an evidence check for every coaching point.</a:t>
+              <a:t>native speakers      : 0.86</a:t>
             </a:r>
           </a:p>
           <a:p>
             <a:pPr>
               <a:spcAft>
-                <a:spcPts val="1500"/>
+                <a:spcPts val="300"/>
               </a:spcAft>
             </a:pPr>
             <a:r>
-              <a:rPr sz="1800" b="0">
-                <a:solidFill>
-                  <a:srgbClr val="1A1F27"/>
-                </a:solidFill>
-                <a:latin typeface="Segoe UI"/>
+              <a:rPr sz="1150" b="0">
+                <a:solidFill>
+                  <a:srgbClr val="0A5B55"/>
+                </a:solidFill>
+                <a:latin typeface="Consolas"/>
               </a:rPr>
-              <a:t>3.   Add a short “model card” per model — its purpose and limits.</a:t>
+              <a:t>non-native speakers  : 0.71</a:t>
             </a:r>
           </a:p>
           <a:p>
             <a:pPr>
               <a:spcAft>
-                <a:spcPts val="1500"/>
+                <a:spcPts val="300"/>
               </a:spcAft>
             </a:pPr>
             <a:r>
-              <a:rPr sz="1800" b="0">
-                <a:solidFill>
-                  <a:srgbClr val="1A1F27"/>
-                </a:solidFill>
-                <a:latin typeface="Segoe UI"/>
+              <a:rPr sz="1150" b="0">
+                <a:solidFill>
+                  <a:srgbClr val="A96E12"/>
+                </a:solidFill>
+                <a:latin typeface="Consolas"/>
               </a:rPr>
-              <a:t>4.   Extend the pre-release check to include fairness and safety.</a:t>
+              <a:t>gap                  : 0.15  → review</a:t>
             </a:r>
           </a:p>
           <a:p>
             <a:pPr>
               <a:spcAft>
-                <a:spcPts val="1500"/>
+                <a:spcPts val="300"/>
               </a:spcAft>
             </a:pPr>
             <a:r>
-              <a:rPr sz="1800" b="0">
+              <a:rPr sz="1150" b="0">
                 <a:solidFill>
                   <a:srgbClr val="1A1F27"/>
                 </a:solidFill>
@@ -5268,17 +6121,261 @@
           <a:p>
             <a:pPr>
               <a:spcAft>
-                <a:spcPts val="1500"/>
+                <a:spcPts val="300"/>
               </a:spcAft>
             </a:pPr>
             <a:r>
-              <a:rPr sz="1800" b="0">
-                <a:solidFill>
-                  <a:srgbClr val="0E7C74"/>
+              <a:rPr sz="1150" b="0">
+                <a:solidFill>
+                  <a:srgbClr val="535C6A"/>
                 </a:solidFill>
                 <a:latin typeface="Segoe UI"/>
               </a:rPr>
-              <a:t>From “protected” today to “governed and trusted” — a step APIX is ready to lead.</a:t>
+              <a:t>A gap isn't proof of bias — but we LOOK,</a:t>
+            </a:r>
+          </a:p>
+          <a:p>
+            <a:pPr>
+              <a:spcAft>
+                <a:spcPts val="300"/>
+              </a:spcAft>
+            </a:pPr>
+            <a:r>
+              <a:rPr sz="1150" b="0">
+                <a:solidFill>
+                  <a:srgbClr val="535C6A"/>
+                </a:solidFill>
+                <a:latin typeface="Segoe UI"/>
+              </a:rPr>
+              <a:t>measure, and explain it, not assume.</a:t>
+            </a:r>
+          </a:p>
+        </p:txBody>
+      </p:sp>
+      <p:sp>
+        <p:nvSpPr>
+          <p:cNvPr id="5" name="Rounded Rectangle 4"/>
+          <p:cNvSpPr/>
+          <p:nvPr/>
+        </p:nvSpPr>
+        <p:spPr>
+          <a:xfrm>
+            <a:off x="6355080" y="1828800"/>
+            <a:ext cx="5212080" cy="3657600"/>
+          </a:xfrm>
+          <a:prstGeom prst="roundRect">
+            <a:avLst/>
+          </a:prstGeom>
+          <a:solidFill>
+            <a:srgbClr val="E1F0EE"/>
+          </a:solidFill>
+          <a:ln w="9525">
+            <a:solidFill>
+              <a:srgbClr val="D9DFE5"/>
+            </a:solidFill>
+          </a:ln>
+          <a:effectLst/>
+        </p:spPr>
+        <p:style>
+          <a:lnRef idx="1">
+            <a:schemeClr val="accent1"/>
+          </a:lnRef>
+          <a:fillRef idx="3">
+            <a:schemeClr val="accent1"/>
+          </a:fillRef>
+          <a:effectRef idx="2">
+            <a:schemeClr val="accent1"/>
+          </a:effectRef>
+          <a:fontRef idx="minor">
+            <a:schemeClr val="lt1"/>
+          </a:fontRef>
+        </p:style>
+        <p:txBody>
+          <a:bodyPr rtlCol="0" anchor="ctr" wrap="square" lIns="146304" rIns="128016" tIns="118872" bIns="91440"/>
+          <a:lstStyle/>
+          <a:p>
+            <a:pPr algn="ctr">
+              <a:spcAft>
+                <a:spcPts val="700"/>
+              </a:spcAft>
+            </a:pPr>
+            <a:r>
+              <a:rPr sz="1250" b="1">
+                <a:solidFill>
+                  <a:srgbClr val="0E7C74"/>
+                </a:solidFill>
+                <a:latin typeface="Segoe UI"/>
+              </a:rPr>
+              <a:t>TRANSPARENCY · a score with its evidence</a:t>
+            </a:r>
+          </a:p>
+          <a:p>
+            <a:pPr>
+              <a:spcAft>
+                <a:spcPts val="300"/>
+              </a:spcAft>
+            </a:pPr>
+            <a:r>
+              <a:rPr sz="1150" b="0">
+                <a:solidFill>
+                  <a:srgbClr val="0A5B55"/>
+                </a:solidFill>
+                <a:latin typeface="Consolas"/>
+              </a:rPr>
+              <a:t>empathy = 0.9</a:t>
+            </a:r>
+          </a:p>
+          <a:p>
+            <a:pPr>
+              <a:spcAft>
+                <a:spcPts val="300"/>
+              </a:spcAft>
+            </a:pPr>
+            <a:r>
+              <a:rPr sz="1150" b="0">
+                <a:solidFill>
+                  <a:srgbClr val="535C6A"/>
+                </a:solidFill>
+                <a:latin typeface="Segoe UI"/>
+              </a:rPr>
+              <a:t>because, on call #4471:</a:t>
+            </a:r>
+          </a:p>
+          <a:p>
+            <a:pPr>
+              <a:spcAft>
+                <a:spcPts val="300"/>
+              </a:spcAft>
+            </a:pPr>
+            <a:r>
+              <a:rPr sz="1150" b="0">
+                <a:solidFill>
+                  <a:srgbClr val="0A5B55"/>
+                </a:solidFill>
+                <a:latin typeface="Consolas"/>
+              </a:rPr>
+              <a:t>  “I completely understand,</a:t>
+            </a:r>
+          </a:p>
+          <a:p>
+            <a:pPr>
+              <a:spcAft>
+                <a:spcPts val="300"/>
+              </a:spcAft>
+            </a:pPr>
+            <a:r>
+              <a:rPr sz="1150" b="0">
+                <a:solidFill>
+                  <a:srgbClr val="0A5B55"/>
+                </a:solidFill>
+                <a:latin typeface="Consolas"/>
+              </a:rPr>
+              <a:t>   let me sort this for you.”</a:t>
+            </a:r>
+          </a:p>
+          <a:p>
+            <a:pPr>
+              <a:spcAft>
+                <a:spcPts val="300"/>
+              </a:spcAft>
+            </a:pPr>
+            <a:r>
+              <a:rPr sz="1150" b="0">
+                <a:solidFill>
+                  <a:srgbClr val="535C6A"/>
+                </a:solidFill>
+                <a:latin typeface="Segoe UI"/>
+              </a:rPr>
+              <a:t>  (lines 12–14)</a:t>
+            </a:r>
+          </a:p>
+          <a:p>
+            <a:pPr>
+              <a:spcAft>
+                <a:spcPts val="300"/>
+              </a:spcAft>
+            </a:pPr>
+            <a:r>
+              <a:rPr sz="1150" b="0">
+                <a:solidFill>
+                  <a:srgbClr val="1A1F27"/>
+                </a:solidFill>
+                <a:latin typeface="Segoe UI"/>
+              </a:rPr>
+              <a:t/>
+            </a:r>
+          </a:p>
+          <a:p>
+            <a:pPr>
+              <a:spcAft>
+                <a:spcPts val="300"/>
+              </a:spcAft>
+            </a:pPr>
+            <a:r>
+              <a:rPr sz="1150" b="0">
+                <a:solidFill>
+                  <a:srgbClr val="2E8B5E"/>
+                </a:solidFill>
+                <a:latin typeface="Segoe UI"/>
+              </a:rPr>
+              <a:t>The agent can see WHY — and challenge it.</a:t>
+            </a:r>
+          </a:p>
+        </p:txBody>
+      </p:sp>
+      <p:sp>
+        <p:nvSpPr>
+          <p:cNvPr id="6" name="Rounded Rectangle 5"/>
+          <p:cNvSpPr/>
+          <p:nvPr/>
+        </p:nvSpPr>
+        <p:spPr>
+          <a:xfrm>
+            <a:off x="640080" y="5806440"/>
+            <a:ext cx="10927080" cy="749808"/>
+          </a:xfrm>
+          <a:prstGeom prst="roundRect">
+            <a:avLst/>
+          </a:prstGeom>
+          <a:solidFill>
+            <a:srgbClr val="E1F0EE"/>
+          </a:solidFill>
+          <a:ln>
+            <a:noFill/>
+          </a:ln>
+          <a:effectLst/>
+        </p:spPr>
+        <p:style>
+          <a:lnRef idx="1">
+            <a:schemeClr val="accent1"/>
+          </a:lnRef>
+          <a:fillRef idx="3">
+            <a:schemeClr val="accent1"/>
+          </a:fillRef>
+          <a:effectRef idx="2">
+            <a:schemeClr val="accent1"/>
+          </a:effectRef>
+          <a:fontRef idx="minor">
+            <a:schemeClr val="lt1"/>
+          </a:fontRef>
+        </p:style>
+        <p:txBody>
+          <a:bodyPr rtlCol="0" anchor="ctr" wrap="square" lIns="201168" rIns="201168"/>
+          <a:lstStyle/>
+          <a:p>
+            <a:pPr algn="ctr">
+              <a:spcAft>
+                <a:spcPts val="0"/>
+              </a:spcAft>
+            </a:pPr>
+            <a:r>
+              <a:rPr sz="1400" b="1">
+                <a:solidFill>
+                  <a:srgbClr val="0A5B55"/>
+                </a:solidFill>
+                <a:latin typeface="Segoe UI"/>
+              </a:rPr>
+              <a:t>Responsible AI turns “trust us” into “here is the check, the number, and the evidence.”</a:t>
             </a:r>
           </a:p>
         </p:txBody>
@@ -5329,6 +6426,7 @@
           <a:ln>
             <a:noFill/>
           </a:ln>
+          <a:effectLst/>
         </p:spPr>
         <p:style>
           <a:lnRef idx="1">
@@ -5360,8 +6458,8 @@
         </p:nvSpPr>
         <p:spPr>
           <a:xfrm>
-            <a:off x="640080" y="384048"/>
-            <a:ext cx="11155680" cy="1280160"/>
+            <a:off x="640080" y="365760"/>
+            <a:ext cx="11247120" cy="1234440"/>
           </a:xfrm>
           <a:prstGeom prst="rect">
             <a:avLst/>
@@ -5376,17 +6474,17 @@
           <a:p>
             <a:pPr>
               <a:spcAft>
-                <a:spcPts val="500"/>
+                <a:spcPts val="400"/>
               </a:spcAft>
             </a:pPr>
             <a:r>
-              <a:rPr sz="1250" b="1">
+              <a:rPr sz="1200" b="1">
                 <a:solidFill>
                   <a:srgbClr val="0E7C74"/>
                 </a:solidFill>
                 <a:latin typeface="Segoe UI"/>
               </a:rPr>
-              <a:t>EXAMPLE</a:t>
+              <a:t>THE PATH</a:t>
             </a:r>
           </a:p>
           <a:p>
@@ -5396,67 +6494,242 @@
               </a:spcAft>
             </a:pPr>
             <a:r>
-              <a:rPr sz="2700" b="1">
+              <a:rPr sz="2500" b="1">
                 <a:solidFill>
                   <a:srgbClr val="1A1F27"/>
                 </a:solidFill>
                 <a:latin typeface="Segoe UI"/>
               </a:rPr>
-              <a:t>A fairness check, in practice</a:t>
-            </a:r>
-          </a:p>
-        </p:txBody>
-      </p:sp>
-      <p:sp>
-        <p:nvSpPr>
-          <p:cNvPr id="4" name="TextBox 3"/>
-          <p:cNvSpPr txBox="1"/>
+              <a:t>From protected today to governed and trusted</a:t>
+            </a:r>
+          </a:p>
+        </p:txBody>
+      </p:sp>
+      <p:sp>
+        <p:nvSpPr>
+          <p:cNvPr id="4" name="Rounded Rectangle 3"/>
+          <p:cNvSpPr/>
           <p:nvPr/>
         </p:nvSpPr>
         <p:spPr>
           <a:xfrm>
-            <a:off x="685800" y="1600200"/>
-            <a:ext cx="10881360" cy="548640"/>
+            <a:off x="640080" y="1828800"/>
+            <a:ext cx="5486400" cy="2286000"/>
           </a:xfrm>
-          <a:prstGeom prst="rect">
+          <a:prstGeom prst="roundRect">
             <a:avLst/>
           </a:prstGeom>
-          <a:noFill/>
+          <a:solidFill>
+            <a:srgbClr val="F6ECD6"/>
+          </a:solidFill>
+          <a:ln w="9525">
+            <a:solidFill>
+              <a:srgbClr val="D9DFE5"/>
+            </a:solidFill>
+          </a:ln>
+          <a:effectLst/>
         </p:spPr>
-        <p:txBody>
-          <a:bodyPr wrap="square">
-            <a:spAutoFit/>
-          </a:bodyPr>
-          <a:lstStyle/>
+        <p:style>
+          <a:lnRef idx="1">
+            <a:schemeClr val="accent1"/>
+          </a:lnRef>
+          <a:fillRef idx="3">
+            <a:schemeClr val="accent1"/>
+          </a:fillRef>
+          <a:effectRef idx="2">
+            <a:schemeClr val="accent1"/>
+          </a:effectRef>
+          <a:fontRef idx="minor">
+            <a:schemeClr val="lt1"/>
+          </a:fontRef>
+        </p:style>
+        <p:txBody>
+          <a:bodyPr rtlCol="0" anchor="ctr" wrap="square" lIns="146304" rIns="128016" tIns="118872" bIns="91440"/>
+          <a:lstStyle/>
+          <a:p>
+            <a:pPr algn="ctr">
+              <a:spcAft>
+                <a:spcPts val="700"/>
+              </a:spcAft>
+            </a:pPr>
+            <a:r>
+              <a:rPr sz="1250" b="1">
+                <a:solidFill>
+                  <a:srgbClr val="A96E12"/>
+                </a:solidFill>
+                <a:latin typeface="Segoe UI"/>
+              </a:rPr>
+              <a:t>TODAY · protected</a:t>
+            </a:r>
+          </a:p>
           <a:p>
             <a:pPr>
               <a:spcAft>
-                <a:spcPts val="0"/>
+                <a:spcPts val="300"/>
               </a:spcAft>
             </a:pPr>
             <a:r>
-              <a:rPr sz="1500" b="0">
+              <a:rPr sz="1150" b="0">
                 <a:solidFill>
                   <a:srgbClr val="535C6A"/>
                 </a:solidFill>
                 <a:latin typeface="Segoe UI"/>
               </a:rPr>
-              <a:t>Is the “language proficiency” score fair? We compare average scores across groups of agents:</a:t>
+              <a:t>Data protection (PII detection)</a:t>
+            </a:r>
+          </a:p>
+          <a:p>
+            <a:pPr>
+              <a:spcAft>
+                <a:spcPts val="300"/>
+              </a:spcAft>
+            </a:pPr>
+            <a:r>
+              <a:rPr sz="1150" b="0">
+                <a:solidFill>
+                  <a:srgbClr val="535C6A"/>
+                </a:solidFill>
+                <a:latin typeface="Segoe UI"/>
+              </a:rPr>
+              <a:t>Basic safety checks</a:t>
+            </a:r>
+          </a:p>
+          <a:p>
+            <a:pPr>
+              <a:spcAft>
+                <a:spcPts val="300"/>
+              </a:spcAft>
+            </a:pPr>
+            <a:r>
+              <a:rPr sz="1150" b="0">
+                <a:solidFill>
+                  <a:srgbClr val="535C6A"/>
+                </a:solidFill>
+                <a:latin typeface="Segoe UI"/>
+              </a:rPr>
+              <a:t>Reliable operations</a:t>
+            </a:r>
+          </a:p>
+        </p:txBody>
+      </p:sp>
+      <p:sp>
+        <p:nvSpPr>
+          <p:cNvPr id="5" name="Rounded Rectangle 4"/>
+          <p:cNvSpPr/>
+          <p:nvPr/>
+        </p:nvSpPr>
+        <p:spPr>
+          <a:xfrm>
+            <a:off x="6355080" y="1828800"/>
+            <a:ext cx="5212080" cy="2286000"/>
+          </a:xfrm>
+          <a:prstGeom prst="roundRect">
+            <a:avLst/>
+          </a:prstGeom>
+          <a:solidFill>
+            <a:srgbClr val="E4F3EB"/>
+          </a:solidFill>
+          <a:ln w="9525">
+            <a:solidFill>
+              <a:srgbClr val="D9DFE5"/>
+            </a:solidFill>
+          </a:ln>
+          <a:effectLst/>
+        </p:spPr>
+        <p:style>
+          <a:lnRef idx="1">
+            <a:schemeClr val="accent1"/>
+          </a:lnRef>
+          <a:fillRef idx="3">
+            <a:schemeClr val="accent1"/>
+          </a:fillRef>
+          <a:effectRef idx="2">
+            <a:schemeClr val="accent1"/>
+          </a:effectRef>
+          <a:fontRef idx="minor">
+            <a:schemeClr val="lt1"/>
+          </a:fontRef>
+        </p:style>
+        <p:txBody>
+          <a:bodyPr rtlCol="0" anchor="ctr" wrap="square" lIns="146304" rIns="128016" tIns="118872" bIns="91440"/>
+          <a:lstStyle/>
+          <a:p>
+            <a:pPr algn="ctr">
+              <a:spcAft>
+                <a:spcPts val="700"/>
+              </a:spcAft>
+            </a:pPr>
+            <a:r>
+              <a:rPr sz="1250" b="1">
+                <a:solidFill>
+                  <a:srgbClr val="2E8B5E"/>
+                </a:solidFill>
+                <a:latin typeface="Segoe UI"/>
+              </a:rPr>
+              <a:t>NEXT · governed &amp; trusted</a:t>
+            </a:r>
+          </a:p>
+          <a:p>
+            <a:pPr>
+              <a:spcAft>
+                <a:spcPts val="300"/>
+              </a:spcAft>
+            </a:pPr>
+            <a:r>
+              <a:rPr sz="1150" b="0">
+                <a:solidFill>
+                  <a:srgbClr val="535C6A"/>
+                </a:solidFill>
+                <a:latin typeface="Segoe UI"/>
+              </a:rPr>
+              <a:t>Fairness checks in the release gate</a:t>
+            </a:r>
+          </a:p>
+          <a:p>
+            <a:pPr>
+              <a:spcAft>
+                <a:spcPts val="300"/>
+              </a:spcAft>
+            </a:pPr>
+            <a:r>
+              <a:rPr sz="1150" b="0">
+                <a:solidFill>
+                  <a:srgbClr val="535C6A"/>
+                </a:solidFill>
+                <a:latin typeface="Segoe UI"/>
+              </a:rPr>
+              <a:t>Evidence + contestability for every score</a:t>
+            </a:r>
+          </a:p>
+          <a:p>
+            <a:pPr>
+              <a:spcAft>
+                <a:spcPts val="300"/>
+              </a:spcAft>
+            </a:pPr>
+            <a:r>
+              <a:rPr sz="1150" b="0">
+                <a:solidFill>
+                  <a:srgbClr val="535C6A"/>
+                </a:solidFill>
+                <a:latin typeface="Segoe UI"/>
+              </a:rPr>
+              <a:t>Model cards; fairness monitoring</a:t>
             </a:r>
           </a:p>
         </p:txBody>
       </p:sp>
       <p:graphicFrame>
         <p:nvGraphicFramePr>
-          <p:cNvPr id="5" name="Table 4"/>
+          <p:cNvPr id="6" name="Table 5"/>
           <p:cNvGraphicFramePr>
             <a:graphicFrameLocks noGrp="1"/>
           </p:cNvGraphicFramePr>
           <p:nvPr/>
         </p:nvGraphicFramePr>
         <p:xfrm>
-          <a:off x="640080" y="2194560"/>
-          <a:ext cx="10927080" cy="2267712"/>
+          <a:off x="640080" y="4343400"/>
+          <a:ext cx="10927080" cy="2011680"/>
         </p:xfrm>
         <a:graphic>
           <a:graphicData uri="http://schemas.openxmlformats.org/drawingml/2006/table">
@@ -5465,10 +6738,10 @@
                 <a:tableStyleId>{5C22544A-7EE6-4342-B048-85BDC9FD1C3A}</a:tableStyleId>
               </a:tblPr>
               <a:tblGrid>
-                <a:gridCol w="5486400"/>
-                <a:gridCol w="5440680"/>
+                <a:gridCol w="8778240"/>
+                <a:gridCol w="2148840"/>
               </a:tblGrid>
-              <a:tr h="566928">
+              <a:tr h="402336">
                 <a:tc>
                   <a:txBody>
                     <a:bodyPr wrap="square"/>
@@ -5481,11 +6754,11 @@
                           </a:solidFill>
                           <a:latin typeface="Segoe UI"/>
                         </a:rPr>
-                        <a:t>Group of agents</a:t>
+                        <a:t>Next steps — start with APIX, reuse for every use case</a:t>
                       </a:r>
                     </a:p>
                   </a:txBody>
-                  <a:tcPr anchor="ctr" marL="91440" marR="54864" marT="27432" marB="27432">
+                  <a:tcPr anchor="ctr" marL="91440" marR="54864" marT="18288" marB="18288">
                     <a:solidFill>
                       <a:srgbClr val="0E7C74"/>
                     </a:solidFill>
@@ -5503,35 +6776,35 @@
                           </a:solidFill>
                           <a:latin typeface="Segoe UI"/>
                         </a:rPr>
-                        <a:t>Average score</a:t>
+                        <a:t/>
                       </a:r>
                     </a:p>
                   </a:txBody>
-                  <a:tcPr anchor="ctr" marL="91440" marR="54864" marT="27432" marB="27432">
+                  <a:tcPr anchor="ctr" marL="91440" marR="54864" marT="18288" marB="18288">
                     <a:solidFill>
                       <a:srgbClr val="0E7C74"/>
                     </a:solidFill>
                   </a:tcPr>
                 </a:tc>
               </a:tr>
-              <a:tr h="566928">
+              <a:tr h="402336">
                 <a:tc>
                   <a:txBody>
                     <a:bodyPr wrap="square"/>
                     <a:lstStyle/>
                     <a:p>
                       <a:r>
-                        <a:rPr sz="1400" b="1">
+                        <a:rPr sz="1300" b="0">
                           <a:solidFill>
-                            <a:srgbClr val="1A1F27"/>
+                            <a:srgbClr val="535C6A"/>
                           </a:solidFill>
                           <a:latin typeface="Segoe UI"/>
                         </a:rPr>
-                        <a:t>Native English speakers</a:t>
+                        <a:t>1 · Fairness check on APIX scores across agent groups</a:t>
                       </a:r>
                     </a:p>
                   </a:txBody>
-                  <a:tcPr anchor="ctr" marL="91440" marR="54864" marT="27432" marB="27432">
+                  <a:tcPr anchor="ctr" marL="91440" marR="54864" marT="18288" marB="18288">
                     <a:solidFill>
                       <a:srgbClr val="FFFFFF"/>
                     </a:solidFill>
@@ -5543,41 +6816,41 @@
                     <a:lstStyle/>
                     <a:p>
                       <a:r>
-                        <a:rPr sz="1400" b="0">
+                        <a:rPr sz="1300" b="0">
                           <a:solidFill>
                             <a:srgbClr val="535C6A"/>
                           </a:solidFill>
                           <a:latin typeface="Segoe UI"/>
                         </a:rPr>
-                        <a:t>0.86</a:t>
+                        <a:t/>
                       </a:r>
                     </a:p>
                   </a:txBody>
-                  <a:tcPr anchor="ctr" marL="91440" marR="54864" marT="27432" marB="27432">
+                  <a:tcPr anchor="ctr" marL="91440" marR="54864" marT="18288" marB="18288">
                     <a:solidFill>
                       <a:srgbClr val="FFFFFF"/>
                     </a:solidFill>
                   </a:tcPr>
                 </a:tc>
               </a:tr>
-              <a:tr h="566928">
+              <a:tr h="402336">
                 <a:tc>
                   <a:txBody>
                     <a:bodyPr wrap="square"/>
                     <a:lstStyle/>
                     <a:p>
                       <a:r>
-                        <a:rPr sz="1400" b="1">
+                        <a:rPr sz="1300" b="0">
                           <a:solidFill>
-                            <a:srgbClr val="1A1F27"/>
+                            <a:srgbClr val="535C6A"/>
                           </a:solidFill>
                           <a:latin typeface="Segoe UI"/>
                         </a:rPr>
-                        <a:t>Non-native English speakers</a:t>
+                        <a:t>2 · Evidence check so every coaching point cites the call</a:t>
                       </a:r>
                     </a:p>
                   </a:txBody>
-                  <a:tcPr anchor="ctr" marL="91440" marR="54864" marT="27432" marB="27432">
+                  <a:tcPr anchor="ctr" marL="91440" marR="54864" marT="18288" marB="18288">
                     <a:solidFill>
                       <a:srgbClr val="F7F9F8"/>
                     </a:solidFill>
@@ -5589,41 +6862,41 @@
                     <a:lstStyle/>
                     <a:p>
                       <a:r>
-                        <a:rPr sz="1400" b="0">
+                        <a:rPr sz="1300" b="0">
                           <a:solidFill>
                             <a:srgbClr val="535C6A"/>
                           </a:solidFill>
                           <a:latin typeface="Segoe UI"/>
                         </a:rPr>
-                        <a:t>0.71</a:t>
+                        <a:t/>
                       </a:r>
                     </a:p>
                   </a:txBody>
-                  <a:tcPr anchor="ctr" marL="91440" marR="54864" marT="27432" marB="27432">
+                  <a:tcPr anchor="ctr" marL="91440" marR="54864" marT="18288" marB="18288">
                     <a:solidFill>
                       <a:srgbClr val="F7F9F8"/>
                     </a:solidFill>
                   </a:tcPr>
                 </a:tc>
               </a:tr>
-              <a:tr h="566928">
+              <a:tr h="402336">
                 <a:tc>
                   <a:txBody>
                     <a:bodyPr wrap="square"/>
                     <a:lstStyle/>
                     <a:p>
                       <a:r>
-                        <a:rPr sz="1400" b="1">
+                        <a:rPr sz="1300" b="0">
                           <a:solidFill>
-                            <a:srgbClr val="1A1F27"/>
+                            <a:srgbClr val="535C6A"/>
                           </a:solidFill>
                           <a:latin typeface="Segoe UI"/>
                         </a:rPr>
-                        <a:t>Gap</a:t>
+                        <a:t>3 · A one-page “model card” per model (purpose + limits)</a:t>
                       </a:r>
                     </a:p>
                   </a:txBody>
-                  <a:tcPr anchor="ctr" marL="91440" marR="54864" marT="27432" marB="27432">
+                  <a:tcPr anchor="ctr" marL="91440" marR="54864" marT="18288" marB="18288">
                     <a:solidFill>
                       <a:srgbClr val="FFFFFF"/>
                     </a:solidFill>
@@ -5635,19 +6908,65 @@
                     <a:lstStyle/>
                     <a:p>
                       <a:r>
-                        <a:rPr sz="1400" b="0">
+                        <a:rPr sz="1300" b="0">
                           <a:solidFill>
                             <a:srgbClr val="535C6A"/>
                           </a:solidFill>
                           <a:latin typeface="Segoe UI"/>
                         </a:rPr>
-                        <a:t>0.15   →   flagged for review</a:t>
+                        <a:t/>
                       </a:r>
                     </a:p>
                   </a:txBody>
-                  <a:tcPr anchor="ctr" marL="91440" marR="54864" marT="27432" marB="27432">
+                  <a:tcPr anchor="ctr" marL="91440" marR="54864" marT="18288" marB="18288">
                     <a:solidFill>
                       <a:srgbClr val="FFFFFF"/>
+                    </a:solidFill>
+                  </a:tcPr>
+                </a:tc>
+              </a:tr>
+              <a:tr h="402336">
+                <a:tc>
+                  <a:txBody>
+                    <a:bodyPr wrap="square"/>
+                    <a:lstStyle/>
+                    <a:p>
+                      <a:r>
+                        <a:rPr sz="1300" b="0">
+                          <a:solidFill>
+                            <a:srgbClr val="535C6A"/>
+                          </a:solidFill>
+                          <a:latin typeface="Segoe UI"/>
+                        </a:rPr>
+                        <a:t>4 · Extend the release gate to include fairness &amp; safety</a:t>
+                      </a:r>
+                    </a:p>
+                  </a:txBody>
+                  <a:tcPr anchor="ctr" marL="91440" marR="54864" marT="18288" marB="18288">
+                    <a:solidFill>
+                      <a:srgbClr val="F7F9F8"/>
+                    </a:solidFill>
+                  </a:tcPr>
+                </a:tc>
+                <a:tc>
+                  <a:txBody>
+                    <a:bodyPr wrap="square"/>
+                    <a:lstStyle/>
+                    <a:p>
+                      <a:r>
+                        <a:rPr sz="1300" b="0">
+                          <a:solidFill>
+                            <a:srgbClr val="535C6A"/>
+                          </a:solidFill>
+                          <a:latin typeface="Segoe UI"/>
+                        </a:rPr>
+                        <a:t/>
+                      </a:r>
+                    </a:p>
+                  </a:txBody>
+                  <a:tcPr anchor="ctr" marL="91440" marR="54864" marT="18288" marB="18288">
+                    <a:solidFill>
+                      <a:srgbClr val="F7F9F8"/>
                     </a:solidFill>
                   </a:tcPr>
                 </a:tc>
@@ -5656,62 +6975,6 @@
           </a:graphicData>
         </a:graphic>
       </p:graphicFrame>
-      <p:sp>
-        <p:nvSpPr>
-          <p:cNvPr id="6" name="Rectangle 5"/>
-          <p:cNvSpPr/>
-          <p:nvPr/>
-        </p:nvSpPr>
-        <p:spPr>
-          <a:xfrm>
-            <a:off x="685800" y="5029200"/>
-            <a:ext cx="10881360" cy="822960"/>
-          </a:xfrm>
-          <a:prstGeom prst="rect">
-            <a:avLst/>
-          </a:prstGeom>
-          <a:solidFill>
-            <a:srgbClr val="F2F5F4"/>
-          </a:solidFill>
-          <a:ln>
-            <a:noFill/>
-          </a:ln>
-        </p:spPr>
-        <p:style>
-          <a:lnRef idx="1">
-            <a:schemeClr val="accent1"/>
-          </a:lnRef>
-          <a:fillRef idx="3">
-            <a:schemeClr val="accent1"/>
-          </a:fillRef>
-          <a:effectRef idx="2">
-            <a:schemeClr val="accent1"/>
-          </a:effectRef>
-          <a:fontRef idx="minor">
-            <a:schemeClr val="lt1"/>
-          </a:fontRef>
-        </p:style>
-        <p:txBody>
-          <a:bodyPr rtlCol="0" anchor="ctr" wrap="square" lIns="228600" rIns="228600"/>
-          <a:lstStyle/>
-          <a:p>
-            <a:pPr algn="ctr">
-              <a:spcAft>
-                <a:spcPts val="0"/>
-              </a:spcAft>
-            </a:pPr>
-            <a:r>
-              <a:rPr sz="1600" b="1">
-                <a:solidFill>
-                  <a:srgbClr val="0E7C74"/>
-                </a:solidFill>
-                <a:latin typeface="Segoe UI"/>
-              </a:rPr>
-              <a:t>A gap doesn't automatically mean bias — but Responsible AI means we look, measure, and explain it, instead of assuming it's fine.</a:t>
-            </a:r>
-          </a:p>
-        </p:txBody>
-      </p:sp>
     </p:spTree>
   </p:cSld>
   <p:clrMapOvr>

</xml_diff>